<commit_message>
Add banner vs push channel analysis slides
Decomposes the funnel by delivery channel from the six-flag pivot
(view/click x banner x notification):

- Banner: 11,183 viewers, 4,490 clicks, 40.2% click rate, 98.7% of clicks
- Push:   78 viewers, 68 clicks, 87.2% click rate, sent to Save Max only

Adds two slides — a channel comparison and a push detail slide covering
the 89.1% rescue rate among recipients who had ignored the banner, the
2.8x within-segment response gap, and the dual-exposure click rate — plus
a stated caveat that push targeting was neither randomized nor held out.
Takeaways updated to reflect the channel lever.

Co-Authored-By: Claude Opus 5 <noreply@anthropic.com>
Claude-Session: https://claude.ai/code/session_01J32T3RCFTYXbmvp9iW7MJu
</commit_message>
<xml_diff>
--- a/decks/campaign_funnel_summary.pptx
+++ b/decks/campaign_funnel_summary.pptx
@@ -11,9 +11,11 @@
     <p:sldId id="259" r:id="rId5"/>
     <p:sldId id="260" r:id="rId6"/>
     <p:sldId id="261" r:id="rId7"/>
+    <p:sldId id="262" r:id="rId8"/>
+    <p:sldId id="263" r:id="rId9"/>
   </p:sldIdLst>
   <p:notesMasterIdLst>
-    <p:notesMasterId r:id="rId8"/>
+    <p:notesMasterId r:id="rId10"/>
   </p:notesMasterIdLst>
   <p:sldSz cx="12192000" cy="6858000"/>
   <p:notesSz cx="6858000" cy="12192000"/>
@@ -1120,6 +1122,296 @@
 </c:chartSpace>
 </file>
 
+<file path=ppt/charts/chart4.xml><?xml version="1.0" encoding="utf-8"?>
+<c:chartSpace xmlns:c="http://schemas.openxmlformats.org/drawingml/2006/chart" xmlns:a="http://schemas.openxmlformats.org/drawingml/2006/main" xmlns:r="http://schemas.openxmlformats.org/officeDocument/2006/relationships">
+  <c:date1904 val="0"/>
+  <c:roundedCorners val="1"/>
+  <c:chart>
+    <c:title>
+      <c:tx>
+        <c:rich>
+          <a:bodyPr/>
+          <a:lstStyle/>
+          <a:p>
+            <a:pPr>
+              <a:defRPr sz="1250" b="0" i="0" u="none" strike="noStrike">
+                <a:solidFill>
+                  <a:srgbClr val="0C2B33"/>
+                </a:solidFill>
+                <a:latin typeface="Calibri"/>
+              </a:defRPr>
+            </a:pPr>
+            <a:r>
+              <a:rPr sz="1250" b="0" i="0" u="none" strike="noStrike">
+                <a:solidFill>
+                  <a:srgbClr val="0C2B33"/>
+                </a:solidFill>
+                <a:latin typeface="Calibri"/>
+              </a:rPr>
+              <a:t>Click rate among those reached</a:t>
+            </a:r>
+          </a:p>
+        </c:rich>
+      </c:tx>
+      <c:layout/>
+      <c:overlay val="0"/>
+    </c:title>
+    <c:autoTitleDeleted val="0"/>
+    <c:plotArea>
+      <c:layout/>
+      <c:barChart>
+        <c:barDir val="col"/>
+        <c:grouping val="clustered"/>
+        <c:varyColors val="0"/>
+        <c:ser>
+          <c:idx val="0"/>
+          <c:order val="0"/>
+          <c:tx>
+            <c:strRef>
+              <c:f>Sheet1!$B$1</c:f>
+              <c:strCache>
+                <c:ptCount val="1"/>
+                <c:pt idx="0">
+                  <c:v>Click rate</c:v>
+                </c:pt>
+              </c:strCache>
+            </c:strRef>
+          </c:tx>
+          <c:spPr>
+            <a:solidFill>
+              <a:srgbClr val="028090"/>
+            </a:solidFill>
+            <a:effectLst/>
+          </c:spPr>
+          <c:invertIfNegative val="0"/>
+          <c:dLbls>
+            <c:numFmt formatCode="0.0&quot;%&quot;" sourceLinked="0"/>
+            <c:txPr>
+              <a:bodyPr/>
+              <a:lstStyle/>
+              <a:p>
+                <a:pPr>
+                  <a:defRPr b="1" i="0" strike="noStrike" sz="1200" u="none">
+                    <a:solidFill>
+                      <a:srgbClr val="33484F"/>
+                    </a:solidFill>
+                    <a:latin typeface="Calibri"/>
+                  </a:defRPr>
+                </a:pPr>
+              </a:p>
+            </c:txPr>
+            <c:showLegendKey val="0"/>
+            <c:showVal val="1"/>
+            <c:showCatName val="0"/>
+            <c:showSerName val="0"/>
+            <c:showPercent val="0"/>
+            <c:showBubbleSize val="0"/>
+            <c:showLeaderLines val="0"/>
+          </c:dLbls>
+          <c:dPt>
+            <c:idx val="0"/>
+            <c:invertIfNegative val="0"/>
+            <c:bubble3D val="0"/>
+            <c:spPr>
+              <a:solidFill>
+                <a:srgbClr val="028090"/>
+              </a:solidFill>
+              <a:effectLst/>
+            </c:spPr>
+          </c:dPt>
+          <c:dPt>
+            <c:idx val="1"/>
+            <c:invertIfNegative val="0"/>
+            <c:bubble3D val="0"/>
+            <c:spPr>
+              <a:solidFill>
+                <a:srgbClr val="02C39A"/>
+              </a:solidFill>
+              <a:effectLst/>
+            </c:spPr>
+          </c:dPt>
+          <c:dPt>
+            <c:idx val="2"/>
+            <c:invertIfNegative val="0"/>
+            <c:bubble3D val="0"/>
+            <c:spPr>
+              <a:solidFill>
+                <a:srgbClr val="7E9AA1"/>
+              </a:solidFill>
+              <a:effectLst/>
+            </c:spPr>
+          </c:dPt>
+          <c:cat>
+            <c:multiLvlStrRef>
+              <c:f>Sheet1!$A$2:$A$4</c:f>
+              <c:multiLvlStrCache>
+                <c:ptCount val="3"/>
+                <c:lvl>
+                  <c:pt idx="0">
+                    <c:v>Banner</c:v>
+                  </c:pt>
+                  <c:pt idx="1">
+                    <c:v>Push notification</c:v>
+                  </c:pt>
+                  <c:pt idx="2">
+                    <c:v>All channels</c:v>
+                  </c:pt>
+                </c:lvl>
+              </c:multiLvlStrCache>
+            </c:multiLvlStrRef>
+          </c:cat>
+          <c:val>
+            <c:numRef>
+              <c:f>Sheet1!$B$2:$B$4</c:f>
+              <c:numCache>
+                <c:formatCode>General</c:formatCode>
+                <c:ptCount val="3"/>
+                <c:pt idx="0">
+                  <c:v>40.2</c:v>
+                </c:pt>
+                <c:pt idx="1">
+                  <c:v>87.2</c:v>
+                </c:pt>
+                <c:pt idx="2">
+                  <c:v>40.7</c:v>
+                </c:pt>
+              </c:numCache>
+            </c:numRef>
+          </c:val>
+        </c:ser>
+        <c:dLbls>
+          <c:numFmt formatCode="0.0&quot;%&quot;" sourceLinked="0"/>
+          <c:txPr>
+            <a:bodyPr/>
+            <a:lstStyle/>
+            <a:p>
+              <a:pPr>
+                <a:defRPr b="1" i="0" strike="noStrike" sz="1200" u="none">
+                  <a:solidFill>
+                    <a:srgbClr val="33484F"/>
+                  </a:solidFill>
+                  <a:latin typeface="Calibri"/>
+                </a:defRPr>
+              </a:pPr>
+            </a:p>
+          </c:txPr>
+          <c:showLegendKey val="0"/>
+          <c:showVal val="1"/>
+          <c:showCatName val="0"/>
+          <c:showSerName val="0"/>
+          <c:showPercent val="0"/>
+          <c:showBubbleSize val="0"/>
+          <c:showLeaderLines val="0"/>
+        </c:dLbls>
+        <c:gapWidth val="70"/>
+        <c:overlap val="0"/>
+        <c:axId val="2094734554"/>
+        <c:axId val="2094734552"/>
+        <c:axId val="2094734556"/>
+      </c:barChart>
+      <c:catAx>
+        <c:axId val="2094734554"/>
+        <c:scaling>
+          <c:orientation val="minMax"/>
+        </c:scaling>
+        <c:delete val="0"/>
+        <c:axPos val="b"/>
+        <c:numFmt formatCode="General" sourceLinked="1"/>
+        <c:majorTickMark val="out"/>
+        <c:minorTickMark val="none"/>
+        <c:tickLblPos val="low"/>
+        <c:spPr>
+          <a:ln w="12700" cap="flat">
+            <a:noFill/>
+            <a:prstDash val="solid"/>
+            <a:round/>
+          </a:ln>
+        </c:spPr>
+        <c:txPr>
+          <a:bodyPr/>
+          <a:lstStyle/>
+          <a:p>
+            <a:pPr>
+              <a:defRPr sz="1150" b="0" i="0" u="none" strike="noStrike">
+                <a:solidFill>
+                  <a:srgbClr val="0C2B33"/>
+                </a:solidFill>
+                <a:latin typeface="Calibri"/>
+              </a:defRPr>
+            </a:pPr>
+            <a:endParaRPr lang="en-US"/>
+          </a:p>
+        </c:txPr>
+        <c:crossAx val="2094734552"/>
+        <c:crosses val="autoZero"/>
+        <c:auto val="1"/>
+        <c:lblAlgn val="ctr"/>
+        <c:noMultiLvlLbl val="1"/>
+      </c:catAx>
+      <c:valAx>
+        <c:axId val="2094734552"/>
+        <c:scaling>
+          <c:orientation val="minMax"/>
+          <c:max val="105"/>
+        </c:scaling>
+        <c:delete val="1"/>
+        <c:axPos val="l"/>
+        <c:numFmt formatCode="General" sourceLinked="0"/>
+        <c:majorTickMark val="out"/>
+        <c:minorTickMark val="none"/>
+        <c:tickLblPos val="nextTo"/>
+        <c:spPr>
+          <a:ln w="12700" cap="flat">
+            <a:solidFill>
+              <a:srgbClr val="888888"/>
+            </a:solidFill>
+            <a:prstDash val="solid"/>
+            <a:round/>
+          </a:ln>
+        </c:spPr>
+        <c:txPr>
+          <a:bodyPr/>
+          <a:lstStyle/>
+          <a:p>
+            <a:pPr>
+              <a:defRPr sz="1200" b="0" i="0" u="none" strike="noStrike">
+                <a:solidFill>
+                  <a:srgbClr val="000000"/>
+                </a:solidFill>
+                <a:latin typeface="Arial"/>
+              </a:defRPr>
+            </a:pPr>
+            <a:endParaRPr lang="en-US"/>
+          </a:p>
+        </c:txPr>
+        <c:crossAx val="2094734554"/>
+        <c:crosses val="autoZero"/>
+        <c:crossBetween val="between"/>
+      </c:valAx>
+      <c:spPr>
+        <a:noFill/>
+        <a:ln>
+          <a:noFill/>
+        </a:ln>
+        <a:effectLst/>
+      </c:spPr>
+    </c:plotArea>
+    <c:plotVisOnly val="1"/>
+    <c:dispBlanksAs val="span"/>
+  </c:chart>
+  <c:spPr>
+    <a:noFill/>
+    <a:ln>
+      <a:noFill/>
+    </a:ln>
+    <a:effectLst/>
+  </c:spPr>
+  <c:externalData r:id="rId1">
+    <c:autoUpdate val="0"/>
+  </c:externalData>
+</c:chartSpace>
+</file>
+
 <file path=ppt/notesMasters/notesMaster1.xml><?xml version="1.0" encoding="utf-8"?>
 <p:notesMaster xmlns:a="http://schemas.openxmlformats.org/drawingml/2006/main" xmlns:r="http://schemas.openxmlformats.org/officeDocument/2006/relationships" xmlns:p="http://schemas.openxmlformats.org/presentationml/2006/main">
   <p:cSld>
@@ -1955,7 +2247,7 @@
           <a:p>
             <a:r>
               <a:rPr lang="en-US" dirty="0"/>
-              <a:t>Priorities ranked by addressable volume: Save Max non-clickers (4,040) are the largest pool, New unreached (1,159) the cheapest lift, Existing the benchmark to protect.</a:t>
+              <a:t>Banner: 11,183 viewers, 4,490 clicks, 40.2%. Push: 78 viewers, 68 clicks, 87.2%. Overlap is 77 viewers / 11 clickers, so the two channels do not sum to the totals. Push is 0.6% of the base but converts 2.2x better.</a:t>
             </a:r>
             <a:endParaRPr lang="en-US" dirty="0"/>
           </a:p>
@@ -1979,6 +2271,182 @@
             <a:fld id="{F7021451-1387-4CA6-816F-3879F97B5CBC}" type="slidenum">
               <a:rPr lang="en-US"/>
               <a:t>6</a:t>
+            </a:fld>
+            <a:endParaRPr lang="en-US"/>
+          </a:p>
+        </p:txBody>
+      </p:sp>
+    </p:spTree>
+    <p:extLst>
+      <p:ext uri="{BB962C8B-B14F-4D97-AF65-F5344CB8AC3E}">
+        <p14:creationId xmlns:p14="http://schemas.microsoft.com/office/powerpoint/2010/main" val="1024086991"/>
+      </p:ext>
+    </p:extLst>
+  </p:cSld>
+  <p:clrMapOvr>
+    <a:masterClrMapping/>
+  </p:clrMapOvr>
+</p:notes>
+</file>
+
+<file path=ppt/notesSlides/notesSlide7.xml><?xml version="1.0" encoding="utf-8"?>
+<p:notes xmlns:a="http://schemas.openxmlformats.org/drawingml/2006/main" xmlns:r="http://schemas.openxmlformats.org/officeDocument/2006/relationships" xmlns:p="http://schemas.openxmlformats.org/presentationml/2006/main">
+  <p:cSld>
+    <p:spTree>
+      <p:nvGrpSpPr>
+        <p:cNvPr id="1" name=""/>
+        <p:cNvGrpSpPr/>
+        <p:nvPr/>
+      </p:nvGrpSpPr>
+      <p:grpSpPr>
+        <a:xfrm>
+          <a:off x="0" y="0"/>
+          <a:ext cx="0" cy="0"/>
+          <a:chOff x="0" y="0"/>
+          <a:chExt cx="0" cy="0"/>
+        </a:xfrm>
+      </p:grpSpPr>
+      <p:sp>
+        <p:nvSpPr>
+          <p:cNvPr id="2" name="Slide Image Placeholder 1"/>
+          <p:cNvSpPr>
+            <a:spLocks noGrp="1" noRot="1" noChangeAspect="1"/>
+          </p:cNvSpPr>
+          <p:nvPr>
+            <p:ph type="sldImg"/>
+          </p:nvPr>
+        </p:nvSpPr>
+        <p:spPr/>
+      </p:sp>
+      <p:sp>
+        <p:nvSpPr>
+          <p:cNvPr id="3" name="Notes Placeholder 2"/>
+          <p:cNvSpPr>
+            <a:spLocks noGrp="1"/>
+          </p:cNvSpPr>
+          <p:nvPr>
+            <p:ph type="body" idx="1"/>
+          </p:nvPr>
+        </p:nvSpPr>
+        <p:spPr/>
+        <p:txBody>
+          <a:bodyPr/>
+          <a:lstStyle/>
+          <a:p>
+            <a:r>
+              <a:rPr lang="en-US" dirty="0"/>
+              <a:t>64 push recipients had seen the banner without clicking; 57 clicked the push (89.1%). Within Save Max, push converts at 87.2% vs 30.9% on banner. Dual-channel viewers click at 90.9% vs 40.3% for banner-only. Caveat: n=78, non-random selection, no holdout.</a:t>
+            </a:r>
+            <a:endParaRPr lang="en-US" dirty="0"/>
+          </a:p>
+        </p:txBody>
+      </p:sp>
+      <p:sp>
+        <p:nvSpPr>
+          <p:cNvPr id="4" name="Slide Number Placeholder 3"/>
+          <p:cNvSpPr>
+            <a:spLocks noGrp="1"/>
+          </p:cNvSpPr>
+          <p:nvPr>
+            <p:ph type="sldNum" sz="quarter" idx="10"/>
+          </p:nvPr>
+        </p:nvSpPr>
+        <p:spPr/>
+        <p:txBody>
+          <a:bodyPr/>
+          <a:lstStyle/>
+          <a:p>
+            <a:fld id="{F7021451-1387-4CA6-816F-3879F97B5CBC}" type="slidenum">
+              <a:rPr lang="en-US"/>
+              <a:t>7</a:t>
+            </a:fld>
+            <a:endParaRPr lang="en-US"/>
+          </a:p>
+        </p:txBody>
+      </p:sp>
+    </p:spTree>
+    <p:extLst>
+      <p:ext uri="{BB962C8B-B14F-4D97-AF65-F5344CB8AC3E}">
+        <p14:creationId xmlns:p14="http://schemas.microsoft.com/office/powerpoint/2010/main" val="1024086991"/>
+      </p:ext>
+    </p:extLst>
+  </p:cSld>
+  <p:clrMapOvr>
+    <a:masterClrMapping/>
+  </p:clrMapOvr>
+</p:notes>
+</file>
+
+<file path=ppt/notesSlides/notesSlide8.xml><?xml version="1.0" encoding="utf-8"?>
+<p:notes xmlns:a="http://schemas.openxmlformats.org/drawingml/2006/main" xmlns:r="http://schemas.openxmlformats.org/officeDocument/2006/relationships" xmlns:p="http://schemas.openxmlformats.org/presentationml/2006/main">
+  <p:cSld>
+    <p:spTree>
+      <p:nvGrpSpPr>
+        <p:cNvPr id="1" name=""/>
+        <p:cNvGrpSpPr/>
+        <p:nvPr/>
+      </p:nvGrpSpPr>
+      <p:grpSpPr>
+        <a:xfrm>
+          <a:off x="0" y="0"/>
+          <a:ext cx="0" cy="0"/>
+          <a:chOff x="0" y="0"/>
+          <a:chExt cx="0" cy="0"/>
+        </a:xfrm>
+      </p:grpSpPr>
+      <p:sp>
+        <p:nvSpPr>
+          <p:cNvPr id="2" name="Slide Image Placeholder 1"/>
+          <p:cNvSpPr>
+            <a:spLocks noGrp="1" noRot="1" noChangeAspect="1"/>
+          </p:cNvSpPr>
+          <p:nvPr>
+            <p:ph type="sldImg"/>
+          </p:nvPr>
+        </p:nvSpPr>
+        <p:spPr/>
+      </p:sp>
+      <p:sp>
+        <p:nvSpPr>
+          <p:cNvPr id="3" name="Notes Placeholder 2"/>
+          <p:cNvSpPr>
+            <a:spLocks noGrp="1"/>
+          </p:cNvSpPr>
+          <p:nvPr>
+            <p:ph type="body" idx="1"/>
+          </p:nvPr>
+        </p:nvSpPr>
+        <p:spPr/>
+        <p:txBody>
+          <a:bodyPr/>
+          <a:lstStyle/>
+          <a:p>
+            <a:r>
+              <a:rPr lang="en-US" dirty="0"/>
+              <a:t>Priorities ranked by addressable volume: Save Max non-clickers (4,040) are the largest pool, New unreached (1,159) the cheapest lift, Existing the benchmark to protect.</a:t>
+            </a:r>
+            <a:endParaRPr lang="en-US" dirty="0"/>
+          </a:p>
+        </p:txBody>
+      </p:sp>
+      <p:sp>
+        <p:nvSpPr>
+          <p:cNvPr id="4" name="Slide Number Placeholder 3"/>
+          <p:cNvSpPr>
+            <a:spLocks noGrp="1"/>
+          </p:cNvSpPr>
+          <p:nvPr>
+            <p:ph type="sldNum" sz="quarter" idx="10"/>
+          </p:nvPr>
+        </p:nvSpPr>
+        <p:spPr/>
+        <p:txBody>
+          <a:bodyPr/>
+          <a:lstStyle/>
+          <a:p>
+            <a:fld id="{F7021451-1387-4CA6-816F-3879F97B5CBC}" type="slidenum">
+              <a:rPr lang="en-US"/>
+              <a:t>8</a:t>
             </a:fld>
             <a:endParaRPr lang="en-US"/>
           </a:p>
@@ -5947,6 +6415,2302 @@
     <p:bg>
       <p:bgPr>
         <a:solidFill>
+          <a:srgbClr val="FFFFFF"/>
+        </a:solidFill>
+      </p:bgPr>
+    </p:bg>
+    <p:spTree>
+      <p:nvGrpSpPr>
+        <p:cNvPr id="1" name=""/>
+        <p:cNvGrpSpPr/>
+        <p:nvPr/>
+      </p:nvGrpSpPr>
+      <p:grpSpPr>
+        <a:xfrm>
+          <a:off x="0" y="0"/>
+          <a:ext cx="0" cy="0"/>
+          <a:chOff x="0" y="0"/>
+          <a:chExt cx="0" cy="0"/>
+        </a:xfrm>
+      </p:grpSpPr>
+      <p:sp>
+        <p:nvSpPr>
+          <p:cNvPr id="2" name="Text 0"/>
+          <p:cNvSpPr/>
+          <p:nvPr/>
+        </p:nvSpPr>
+        <p:spPr>
+          <a:xfrm>
+            <a:off x="548640" y="384048"/>
+            <a:ext cx="8229600" cy="256032"/>
+          </a:xfrm>
+          <a:prstGeom prst="rect">
+            <a:avLst/>
+          </a:prstGeom>
+          <a:noFill/>
+          <a:ln/>
+        </p:spPr>
+        <p:txBody>
+          <a:bodyPr wrap="square" lIns="0" tIns="0" rIns="0" bIns="0" rtlCol="0" anchor="ctr"/>
+          <a:lstStyle/>
+          <a:p>
+            <a:pPr indent="0" marL="0">
+              <a:buNone/>
+            </a:pPr>
+            <a:r>
+              <a:rPr lang="en-US" sz="1150" b="1" spc="200" kern="0" dirty="0">
+                <a:solidFill>
+                  <a:srgbClr val="028090"/>
+                </a:solidFill>
+                <a:latin typeface="Calibri" pitchFamily="34" charset="0"/>
+                <a:ea typeface="Calibri" pitchFamily="34" charset="-122"/>
+                <a:cs typeface="Calibri" pitchFamily="34" charset="-120"/>
+              </a:rPr>
+              <a:t>CHANNEL MIX</a:t>
+            </a:r>
+            <a:endParaRPr lang="en-US" sz="1150" dirty="0"/>
+          </a:p>
+        </p:txBody>
+      </p:sp>
+      <p:sp>
+        <p:nvSpPr>
+          <p:cNvPr id="3" name="Text 1"/>
+          <p:cNvSpPr/>
+          <p:nvPr/>
+        </p:nvSpPr>
+        <p:spPr>
+          <a:xfrm>
+            <a:off x="548640" y="694944"/>
+            <a:ext cx="10607040" cy="658368"/>
+          </a:xfrm>
+          <a:prstGeom prst="rect">
+            <a:avLst/>
+          </a:prstGeom>
+          <a:noFill/>
+          <a:ln/>
+        </p:spPr>
+        <p:txBody>
+          <a:bodyPr wrap="square" lIns="0" tIns="0" rIns="0" bIns="0" rtlCol="0" anchor="ctr"/>
+          <a:lstStyle/>
+          <a:p>
+            <a:pPr indent="0" marL="0">
+              <a:buNone/>
+            </a:pPr>
+            <a:r>
+              <a:rPr lang="en-US" sz="3200" b="1" dirty="0">
+                <a:solidFill>
+                  <a:srgbClr val="0C2B33"/>
+                </a:solidFill>
+                <a:latin typeface="Cambria" pitchFamily="34" charset="0"/>
+                <a:ea typeface="Cambria" pitchFamily="34" charset="-122"/>
+                <a:cs typeface="Cambria" pitchFamily="34" charset="-120"/>
+              </a:rPr>
+              <a:t>Two channels, opposite profiles</a:t>
+            </a:r>
+            <a:endParaRPr lang="en-US" sz="3200" dirty="0"/>
+          </a:p>
+        </p:txBody>
+      </p:sp>
+      <p:sp>
+        <p:nvSpPr>
+          <p:cNvPr id="4" name="Text 2"/>
+          <p:cNvSpPr/>
+          <p:nvPr/>
+        </p:nvSpPr>
+        <p:spPr>
+          <a:xfrm>
+            <a:off x="548640" y="1335024"/>
+            <a:ext cx="10607040" cy="310896"/>
+          </a:xfrm>
+          <a:prstGeom prst="rect">
+            <a:avLst/>
+          </a:prstGeom>
+          <a:noFill/>
+          <a:ln/>
+        </p:spPr>
+        <p:txBody>
+          <a:bodyPr wrap="square" lIns="0" tIns="0" rIns="0" bIns="0" rtlCol="0" anchor="ctr"/>
+          <a:lstStyle/>
+          <a:p>
+            <a:pPr indent="0" marL="0">
+              <a:buNone/>
+            </a:pPr>
+            <a:r>
+              <a:rPr lang="en-US" sz="1400" dirty="0">
+                <a:solidFill>
+                  <a:srgbClr val="6E878E"/>
+                </a:solidFill>
+                <a:latin typeface="Calibri" pitchFamily="34" charset="0"/>
+                <a:ea typeface="Calibri" pitchFamily="34" charset="-122"/>
+                <a:cs typeface="Calibri" pitchFamily="34" charset="-120"/>
+              </a:rPr>
+              <a:t>Banner carried the reach. Push notification carried the conversion.</a:t>
+            </a:r>
+            <a:endParaRPr lang="en-US" sz="1400" dirty="0"/>
+          </a:p>
+        </p:txBody>
+      </p:sp>
+      <p:sp>
+        <p:nvSpPr>
+          <p:cNvPr id="5" name="Shape 3"/>
+          <p:cNvSpPr/>
+          <p:nvPr/>
+        </p:nvSpPr>
+        <p:spPr>
+          <a:xfrm>
+            <a:off x="548640" y="1737360"/>
+            <a:ext cx="5394960" cy="2011680"/>
+          </a:xfrm>
+          <a:prstGeom prst="roundRect">
+            <a:avLst>
+              <a:gd name="adj" fmla="val 4545"/>
+            </a:avLst>
+          </a:prstGeom>
+          <a:solidFill>
+            <a:srgbClr val="EEF5F5"/>
+          </a:solidFill>
+          <a:ln w="12700">
+            <a:solidFill>
+              <a:srgbClr val="DDE9E9"/>
+            </a:solidFill>
+            <a:prstDash val="solid"/>
+          </a:ln>
+          <a:effectLst>
+            <a:outerShdw sx="100000" sy="100000" kx="0" ky="0" algn="bl" rotWithShape="0" blurRad="127000" dist="25400" dir="5400000">
+              <a:srgbClr val="0C2B33">
+                <a:alpha val="10000"/>
+              </a:srgbClr>
+            </a:outerShdw>
+          </a:effectLst>
+        </p:spPr>
+      </p:sp>
+      <p:sp>
+        <p:nvSpPr>
+          <p:cNvPr id="6" name="Shape 4"/>
+          <p:cNvSpPr/>
+          <p:nvPr/>
+        </p:nvSpPr>
+        <p:spPr>
+          <a:xfrm>
+            <a:off x="841248" y="2011680"/>
+            <a:ext cx="237744" cy="237744"/>
+          </a:xfrm>
+          <a:prstGeom prst="ellipse">
+            <a:avLst/>
+          </a:prstGeom>
+          <a:solidFill>
+            <a:srgbClr val="028090"/>
+          </a:solidFill>
+          <a:ln w="12700">
+            <a:solidFill>
+              <a:srgbClr val="028090"/>
+            </a:solidFill>
+            <a:prstDash val="solid"/>
+          </a:ln>
+        </p:spPr>
+      </p:sp>
+      <p:sp>
+        <p:nvSpPr>
+          <p:cNvPr id="7" name="Text 5"/>
+          <p:cNvSpPr/>
+          <p:nvPr/>
+        </p:nvSpPr>
+        <p:spPr>
+          <a:xfrm>
+            <a:off x="1170432" y="1956816"/>
+            <a:ext cx="4480560" cy="347472"/>
+          </a:xfrm>
+          <a:prstGeom prst="rect">
+            <a:avLst/>
+          </a:prstGeom>
+          <a:noFill/>
+          <a:ln/>
+        </p:spPr>
+        <p:txBody>
+          <a:bodyPr wrap="square" lIns="0" tIns="0" rIns="0" bIns="0" rtlCol="0" anchor="ctr"/>
+          <a:lstStyle/>
+          <a:p>
+            <a:pPr indent="0" marL="0">
+              <a:buNone/>
+            </a:pPr>
+            <a:r>
+              <a:rPr lang="en-US" sz="1500" b="1" dirty="0">
+                <a:solidFill>
+                  <a:srgbClr val="0C2B33"/>
+                </a:solidFill>
+                <a:latin typeface="Calibri" pitchFamily="34" charset="0"/>
+                <a:ea typeface="Calibri" pitchFamily="34" charset="-122"/>
+                <a:cs typeface="Calibri" pitchFamily="34" charset="-120"/>
+              </a:rPr>
+              <a:t>Banner</a:t>
+            </a:r>
+            <a:endParaRPr lang="en-US" sz="1500" dirty="0"/>
+          </a:p>
+        </p:txBody>
+      </p:sp>
+      <p:sp>
+        <p:nvSpPr>
+          <p:cNvPr id="8" name="Text 6"/>
+          <p:cNvSpPr/>
+          <p:nvPr/>
+        </p:nvSpPr>
+        <p:spPr>
+          <a:xfrm>
+            <a:off x="841248" y="2395728"/>
+            <a:ext cx="1645920" cy="548640"/>
+          </a:xfrm>
+          <a:prstGeom prst="rect">
+            <a:avLst/>
+          </a:prstGeom>
+          <a:noFill/>
+          <a:ln/>
+        </p:spPr>
+        <p:txBody>
+          <a:bodyPr wrap="square" lIns="0" tIns="0" rIns="0" bIns="0" rtlCol="0" anchor="ctr"/>
+          <a:lstStyle/>
+          <a:p>
+            <a:pPr indent="0" marL="0">
+              <a:buNone/>
+            </a:pPr>
+            <a:r>
+              <a:rPr lang="en-US" sz="2600" b="1" dirty="0">
+                <a:solidFill>
+                  <a:srgbClr val="0C2B33"/>
+                </a:solidFill>
+                <a:latin typeface="Cambria" pitchFamily="34" charset="0"/>
+                <a:ea typeface="Cambria" pitchFamily="34" charset="-122"/>
+                <a:cs typeface="Cambria" pitchFamily="34" charset="-120"/>
+              </a:rPr>
+              <a:t>11,183</a:t>
+            </a:r>
+            <a:endParaRPr lang="en-US" sz="2600" dirty="0"/>
+          </a:p>
+        </p:txBody>
+      </p:sp>
+      <p:sp>
+        <p:nvSpPr>
+          <p:cNvPr id="9" name="Text 7"/>
+          <p:cNvSpPr/>
+          <p:nvPr/>
+        </p:nvSpPr>
+        <p:spPr>
+          <a:xfrm>
+            <a:off x="841248" y="2926080"/>
+            <a:ext cx="1645920" cy="256032"/>
+          </a:xfrm>
+          <a:prstGeom prst="rect">
+            <a:avLst/>
+          </a:prstGeom>
+          <a:noFill/>
+          <a:ln/>
+        </p:spPr>
+        <p:txBody>
+          <a:bodyPr wrap="square" lIns="0" tIns="0" rIns="0" bIns="0" rtlCol="0" anchor="ctr"/>
+          <a:lstStyle/>
+          <a:p>
+            <a:pPr indent="0" marL="0">
+              <a:buNone/>
+            </a:pPr>
+            <a:r>
+              <a:rPr lang="en-US" sz="1100" dirty="0">
+                <a:solidFill>
+                  <a:srgbClr val="6E878E"/>
+                </a:solidFill>
+                <a:latin typeface="Calibri" pitchFamily="34" charset="0"/>
+                <a:ea typeface="Calibri" pitchFamily="34" charset="-122"/>
+                <a:cs typeface="Calibri" pitchFamily="34" charset="-120"/>
+              </a:rPr>
+              <a:t>viewers</a:t>
+            </a:r>
+            <a:endParaRPr lang="en-US" sz="1100" dirty="0"/>
+          </a:p>
+        </p:txBody>
+      </p:sp>
+      <p:sp>
+        <p:nvSpPr>
+          <p:cNvPr id="10" name="Text 8"/>
+          <p:cNvSpPr/>
+          <p:nvPr/>
+        </p:nvSpPr>
+        <p:spPr>
+          <a:xfrm>
+            <a:off x="2532888" y="2395728"/>
+            <a:ext cx="1645920" cy="548640"/>
+          </a:xfrm>
+          <a:prstGeom prst="rect">
+            <a:avLst/>
+          </a:prstGeom>
+          <a:noFill/>
+          <a:ln/>
+        </p:spPr>
+        <p:txBody>
+          <a:bodyPr wrap="square" lIns="0" tIns="0" rIns="0" bIns="0" rtlCol="0" anchor="ctr"/>
+          <a:lstStyle/>
+          <a:p>
+            <a:pPr indent="0" marL="0">
+              <a:buNone/>
+            </a:pPr>
+            <a:r>
+              <a:rPr lang="en-US" sz="2600" b="1" dirty="0">
+                <a:solidFill>
+                  <a:srgbClr val="0C2B33"/>
+                </a:solidFill>
+                <a:latin typeface="Cambria" pitchFamily="34" charset="0"/>
+                <a:ea typeface="Cambria" pitchFamily="34" charset="-122"/>
+                <a:cs typeface="Cambria" pitchFamily="34" charset="-120"/>
+              </a:rPr>
+              <a:t>4,490</a:t>
+            </a:r>
+            <a:endParaRPr lang="en-US" sz="2600" dirty="0"/>
+          </a:p>
+        </p:txBody>
+      </p:sp>
+      <p:sp>
+        <p:nvSpPr>
+          <p:cNvPr id="11" name="Text 9"/>
+          <p:cNvSpPr/>
+          <p:nvPr/>
+        </p:nvSpPr>
+        <p:spPr>
+          <a:xfrm>
+            <a:off x="2532888" y="2926080"/>
+            <a:ext cx="1645920" cy="256032"/>
+          </a:xfrm>
+          <a:prstGeom prst="rect">
+            <a:avLst/>
+          </a:prstGeom>
+          <a:noFill/>
+          <a:ln/>
+        </p:spPr>
+        <p:txBody>
+          <a:bodyPr wrap="square" lIns="0" tIns="0" rIns="0" bIns="0" rtlCol="0" anchor="ctr"/>
+          <a:lstStyle/>
+          <a:p>
+            <a:pPr indent="0" marL="0">
+              <a:buNone/>
+            </a:pPr>
+            <a:r>
+              <a:rPr lang="en-US" sz="1100" dirty="0">
+                <a:solidFill>
+                  <a:srgbClr val="6E878E"/>
+                </a:solidFill>
+                <a:latin typeface="Calibri" pitchFamily="34" charset="0"/>
+                <a:ea typeface="Calibri" pitchFamily="34" charset="-122"/>
+                <a:cs typeface="Calibri" pitchFamily="34" charset="-120"/>
+              </a:rPr>
+              <a:t>clicks</a:t>
+            </a:r>
+            <a:endParaRPr lang="en-US" sz="1100" dirty="0"/>
+          </a:p>
+        </p:txBody>
+      </p:sp>
+      <p:sp>
+        <p:nvSpPr>
+          <p:cNvPr id="12" name="Text 10"/>
+          <p:cNvSpPr/>
+          <p:nvPr/>
+        </p:nvSpPr>
+        <p:spPr>
+          <a:xfrm>
+            <a:off x="4224528" y="2395728"/>
+            <a:ext cx="1645920" cy="548640"/>
+          </a:xfrm>
+          <a:prstGeom prst="rect">
+            <a:avLst/>
+          </a:prstGeom>
+          <a:noFill/>
+          <a:ln/>
+        </p:spPr>
+        <p:txBody>
+          <a:bodyPr wrap="square" lIns="0" tIns="0" rIns="0" bIns="0" rtlCol="0" anchor="ctr"/>
+          <a:lstStyle/>
+          <a:p>
+            <a:pPr indent="0" marL="0">
+              <a:buNone/>
+            </a:pPr>
+            <a:r>
+              <a:rPr lang="en-US" sz="2600" b="1" dirty="0">
+                <a:solidFill>
+                  <a:srgbClr val="028090"/>
+                </a:solidFill>
+                <a:latin typeface="Cambria" pitchFamily="34" charset="0"/>
+                <a:ea typeface="Cambria" pitchFamily="34" charset="-122"/>
+                <a:cs typeface="Cambria" pitchFamily="34" charset="-120"/>
+              </a:rPr>
+              <a:t>40.2%</a:t>
+            </a:r>
+            <a:endParaRPr lang="en-US" sz="2600" dirty="0"/>
+          </a:p>
+        </p:txBody>
+      </p:sp>
+      <p:sp>
+        <p:nvSpPr>
+          <p:cNvPr id="13" name="Text 11"/>
+          <p:cNvSpPr/>
+          <p:nvPr/>
+        </p:nvSpPr>
+        <p:spPr>
+          <a:xfrm>
+            <a:off x="4224528" y="2926080"/>
+            <a:ext cx="1645920" cy="256032"/>
+          </a:xfrm>
+          <a:prstGeom prst="rect">
+            <a:avLst/>
+          </a:prstGeom>
+          <a:noFill/>
+          <a:ln/>
+        </p:spPr>
+        <p:txBody>
+          <a:bodyPr wrap="square" lIns="0" tIns="0" rIns="0" bIns="0" rtlCol="0" anchor="ctr"/>
+          <a:lstStyle/>
+          <a:p>
+            <a:pPr indent="0" marL="0">
+              <a:buNone/>
+            </a:pPr>
+            <a:r>
+              <a:rPr lang="en-US" sz="1100" dirty="0">
+                <a:solidFill>
+                  <a:srgbClr val="6E878E"/>
+                </a:solidFill>
+                <a:latin typeface="Calibri" pitchFamily="34" charset="0"/>
+                <a:ea typeface="Calibri" pitchFamily="34" charset="-122"/>
+                <a:cs typeface="Calibri" pitchFamily="34" charset="-120"/>
+              </a:rPr>
+              <a:t>click rate</a:t>
+            </a:r>
+            <a:endParaRPr lang="en-US" sz="1100" dirty="0"/>
+          </a:p>
+        </p:txBody>
+      </p:sp>
+      <p:sp>
+        <p:nvSpPr>
+          <p:cNvPr id="14" name="Text 12"/>
+          <p:cNvSpPr/>
+          <p:nvPr/>
+        </p:nvSpPr>
+        <p:spPr>
+          <a:xfrm>
+            <a:off x="841248" y="3255264"/>
+            <a:ext cx="4809744" cy="402336"/>
+          </a:xfrm>
+          <a:prstGeom prst="rect">
+            <a:avLst/>
+          </a:prstGeom>
+          <a:noFill/>
+          <a:ln/>
+        </p:spPr>
+        <p:txBody>
+          <a:bodyPr wrap="square" lIns="0" tIns="0" rIns="0" bIns="0" rtlCol="0" anchor="ctr"/>
+          <a:lstStyle/>
+          <a:p>
+            <a:pPr indent="0" marL="0">
+              <a:buNone/>
+            </a:pPr>
+            <a:r>
+              <a:rPr lang="en-US" sz="1150" dirty="0">
+                <a:solidFill>
+                  <a:srgbClr val="33484F"/>
+                </a:solidFill>
+                <a:latin typeface="Calibri" pitchFamily="34" charset="0"/>
+                <a:ea typeface="Calibri" pitchFamily="34" charset="-122"/>
+                <a:cs typeface="Calibri" pitchFamily="34" charset="-120"/>
+              </a:rPr>
+              <a:t>Reached 83.9% of the base and delivered 98.7% of every click.</a:t>
+            </a:r>
+            <a:endParaRPr lang="en-US" sz="1150" dirty="0"/>
+          </a:p>
+        </p:txBody>
+      </p:sp>
+      <p:sp>
+        <p:nvSpPr>
+          <p:cNvPr id="15" name="Shape 13"/>
+          <p:cNvSpPr/>
+          <p:nvPr/>
+        </p:nvSpPr>
+        <p:spPr>
+          <a:xfrm>
+            <a:off x="6217920" y="1737360"/>
+            <a:ext cx="5394960" cy="2011680"/>
+          </a:xfrm>
+          <a:prstGeom prst="roundRect">
+            <a:avLst>
+              <a:gd name="adj" fmla="val 4545"/>
+            </a:avLst>
+          </a:prstGeom>
+          <a:solidFill>
+            <a:srgbClr val="EEF5F5"/>
+          </a:solidFill>
+          <a:ln w="12700">
+            <a:solidFill>
+              <a:srgbClr val="DDE9E9"/>
+            </a:solidFill>
+            <a:prstDash val="solid"/>
+          </a:ln>
+          <a:effectLst>
+            <a:outerShdw sx="100000" sy="100000" kx="0" ky="0" algn="bl" rotWithShape="0" blurRad="127000" dist="25400" dir="5400000">
+              <a:srgbClr val="0C2B33">
+                <a:alpha val="10000"/>
+              </a:srgbClr>
+            </a:outerShdw>
+          </a:effectLst>
+        </p:spPr>
+      </p:sp>
+      <p:sp>
+        <p:nvSpPr>
+          <p:cNvPr id="16" name="Shape 14"/>
+          <p:cNvSpPr/>
+          <p:nvPr/>
+        </p:nvSpPr>
+        <p:spPr>
+          <a:xfrm>
+            <a:off x="6510528" y="2011680"/>
+            <a:ext cx="237744" cy="237744"/>
+          </a:xfrm>
+          <a:prstGeom prst="ellipse">
+            <a:avLst/>
+          </a:prstGeom>
+          <a:solidFill>
+            <a:srgbClr val="02C39A"/>
+          </a:solidFill>
+          <a:ln w="12700">
+            <a:solidFill>
+              <a:srgbClr val="02C39A"/>
+            </a:solidFill>
+            <a:prstDash val="solid"/>
+          </a:ln>
+        </p:spPr>
+      </p:sp>
+      <p:sp>
+        <p:nvSpPr>
+          <p:cNvPr id="17" name="Text 15"/>
+          <p:cNvSpPr/>
+          <p:nvPr/>
+        </p:nvSpPr>
+        <p:spPr>
+          <a:xfrm>
+            <a:off x="6839712" y="1956816"/>
+            <a:ext cx="4480560" cy="347472"/>
+          </a:xfrm>
+          <a:prstGeom prst="rect">
+            <a:avLst/>
+          </a:prstGeom>
+          <a:noFill/>
+          <a:ln/>
+        </p:spPr>
+        <p:txBody>
+          <a:bodyPr wrap="square" lIns="0" tIns="0" rIns="0" bIns="0" rtlCol="0" anchor="ctr"/>
+          <a:lstStyle/>
+          <a:p>
+            <a:pPr indent="0" marL="0">
+              <a:buNone/>
+            </a:pPr>
+            <a:r>
+              <a:rPr lang="en-US" sz="1500" b="1" dirty="0">
+                <a:solidFill>
+                  <a:srgbClr val="0C2B33"/>
+                </a:solidFill>
+                <a:latin typeface="Calibri" pitchFamily="34" charset="0"/>
+                <a:ea typeface="Calibri" pitchFamily="34" charset="-122"/>
+                <a:cs typeface="Calibri" pitchFamily="34" charset="-120"/>
+              </a:rPr>
+              <a:t>Push notification</a:t>
+            </a:r>
+            <a:endParaRPr lang="en-US" sz="1500" dirty="0"/>
+          </a:p>
+        </p:txBody>
+      </p:sp>
+      <p:sp>
+        <p:nvSpPr>
+          <p:cNvPr id="18" name="Text 16"/>
+          <p:cNvSpPr/>
+          <p:nvPr/>
+        </p:nvSpPr>
+        <p:spPr>
+          <a:xfrm>
+            <a:off x="6510528" y="2395728"/>
+            <a:ext cx="1645920" cy="548640"/>
+          </a:xfrm>
+          <a:prstGeom prst="rect">
+            <a:avLst/>
+          </a:prstGeom>
+          <a:noFill/>
+          <a:ln/>
+        </p:spPr>
+        <p:txBody>
+          <a:bodyPr wrap="square" lIns="0" tIns="0" rIns="0" bIns="0" rtlCol="0" anchor="ctr"/>
+          <a:lstStyle/>
+          <a:p>
+            <a:pPr indent="0" marL="0">
+              <a:buNone/>
+            </a:pPr>
+            <a:r>
+              <a:rPr lang="en-US" sz="2600" b="1" dirty="0">
+                <a:solidFill>
+                  <a:srgbClr val="0C2B33"/>
+                </a:solidFill>
+                <a:latin typeface="Cambria" pitchFamily="34" charset="0"/>
+                <a:ea typeface="Cambria" pitchFamily="34" charset="-122"/>
+                <a:cs typeface="Cambria" pitchFamily="34" charset="-120"/>
+              </a:rPr>
+              <a:t>78</a:t>
+            </a:r>
+            <a:endParaRPr lang="en-US" sz="2600" dirty="0"/>
+          </a:p>
+        </p:txBody>
+      </p:sp>
+      <p:sp>
+        <p:nvSpPr>
+          <p:cNvPr id="19" name="Text 17"/>
+          <p:cNvSpPr/>
+          <p:nvPr/>
+        </p:nvSpPr>
+        <p:spPr>
+          <a:xfrm>
+            <a:off x="6510528" y="2926080"/>
+            <a:ext cx="1645920" cy="256032"/>
+          </a:xfrm>
+          <a:prstGeom prst="rect">
+            <a:avLst/>
+          </a:prstGeom>
+          <a:noFill/>
+          <a:ln/>
+        </p:spPr>
+        <p:txBody>
+          <a:bodyPr wrap="square" lIns="0" tIns="0" rIns="0" bIns="0" rtlCol="0" anchor="ctr"/>
+          <a:lstStyle/>
+          <a:p>
+            <a:pPr indent="0" marL="0">
+              <a:buNone/>
+            </a:pPr>
+            <a:r>
+              <a:rPr lang="en-US" sz="1100" dirty="0">
+                <a:solidFill>
+                  <a:srgbClr val="6E878E"/>
+                </a:solidFill>
+                <a:latin typeface="Calibri" pitchFamily="34" charset="0"/>
+                <a:ea typeface="Calibri" pitchFamily="34" charset="-122"/>
+                <a:cs typeface="Calibri" pitchFamily="34" charset="-120"/>
+              </a:rPr>
+              <a:t>viewers</a:t>
+            </a:r>
+            <a:endParaRPr lang="en-US" sz="1100" dirty="0"/>
+          </a:p>
+        </p:txBody>
+      </p:sp>
+      <p:sp>
+        <p:nvSpPr>
+          <p:cNvPr id="20" name="Text 18"/>
+          <p:cNvSpPr/>
+          <p:nvPr/>
+        </p:nvSpPr>
+        <p:spPr>
+          <a:xfrm>
+            <a:off x="8202168" y="2395728"/>
+            <a:ext cx="1645920" cy="548640"/>
+          </a:xfrm>
+          <a:prstGeom prst="rect">
+            <a:avLst/>
+          </a:prstGeom>
+          <a:noFill/>
+          <a:ln/>
+        </p:spPr>
+        <p:txBody>
+          <a:bodyPr wrap="square" lIns="0" tIns="0" rIns="0" bIns="0" rtlCol="0" anchor="ctr"/>
+          <a:lstStyle/>
+          <a:p>
+            <a:pPr indent="0" marL="0">
+              <a:buNone/>
+            </a:pPr>
+            <a:r>
+              <a:rPr lang="en-US" sz="2600" b="1" dirty="0">
+                <a:solidFill>
+                  <a:srgbClr val="0C2B33"/>
+                </a:solidFill>
+                <a:latin typeface="Cambria" pitchFamily="34" charset="0"/>
+                <a:ea typeface="Cambria" pitchFamily="34" charset="-122"/>
+                <a:cs typeface="Cambria" pitchFamily="34" charset="-120"/>
+              </a:rPr>
+              <a:t>68</a:t>
+            </a:r>
+            <a:endParaRPr lang="en-US" sz="2600" dirty="0"/>
+          </a:p>
+        </p:txBody>
+      </p:sp>
+      <p:sp>
+        <p:nvSpPr>
+          <p:cNvPr id="21" name="Text 19"/>
+          <p:cNvSpPr/>
+          <p:nvPr/>
+        </p:nvSpPr>
+        <p:spPr>
+          <a:xfrm>
+            <a:off x="8202168" y="2926080"/>
+            <a:ext cx="1645920" cy="256032"/>
+          </a:xfrm>
+          <a:prstGeom prst="rect">
+            <a:avLst/>
+          </a:prstGeom>
+          <a:noFill/>
+          <a:ln/>
+        </p:spPr>
+        <p:txBody>
+          <a:bodyPr wrap="square" lIns="0" tIns="0" rIns="0" bIns="0" rtlCol="0" anchor="ctr"/>
+          <a:lstStyle/>
+          <a:p>
+            <a:pPr indent="0" marL="0">
+              <a:buNone/>
+            </a:pPr>
+            <a:r>
+              <a:rPr lang="en-US" sz="1100" dirty="0">
+                <a:solidFill>
+                  <a:srgbClr val="6E878E"/>
+                </a:solidFill>
+                <a:latin typeface="Calibri" pitchFamily="34" charset="0"/>
+                <a:ea typeface="Calibri" pitchFamily="34" charset="-122"/>
+                <a:cs typeface="Calibri" pitchFamily="34" charset="-120"/>
+              </a:rPr>
+              <a:t>clicks</a:t>
+            </a:r>
+            <a:endParaRPr lang="en-US" sz="1100" dirty="0"/>
+          </a:p>
+        </p:txBody>
+      </p:sp>
+      <p:sp>
+        <p:nvSpPr>
+          <p:cNvPr id="22" name="Text 20"/>
+          <p:cNvSpPr/>
+          <p:nvPr/>
+        </p:nvSpPr>
+        <p:spPr>
+          <a:xfrm>
+            <a:off x="9893808" y="2395728"/>
+            <a:ext cx="1645920" cy="548640"/>
+          </a:xfrm>
+          <a:prstGeom prst="rect">
+            <a:avLst/>
+          </a:prstGeom>
+          <a:noFill/>
+          <a:ln/>
+        </p:spPr>
+        <p:txBody>
+          <a:bodyPr wrap="square" lIns="0" tIns="0" rIns="0" bIns="0" rtlCol="0" anchor="ctr"/>
+          <a:lstStyle/>
+          <a:p>
+            <a:pPr indent="0" marL="0">
+              <a:buNone/>
+            </a:pPr>
+            <a:r>
+              <a:rPr lang="en-US" sz="2600" b="1" dirty="0">
+                <a:solidFill>
+                  <a:srgbClr val="02C39A"/>
+                </a:solidFill>
+                <a:latin typeface="Cambria" pitchFamily="34" charset="0"/>
+                <a:ea typeface="Cambria" pitchFamily="34" charset="-122"/>
+                <a:cs typeface="Cambria" pitchFamily="34" charset="-120"/>
+              </a:rPr>
+              <a:t>87.2%</a:t>
+            </a:r>
+            <a:endParaRPr lang="en-US" sz="2600" dirty="0"/>
+          </a:p>
+        </p:txBody>
+      </p:sp>
+      <p:sp>
+        <p:nvSpPr>
+          <p:cNvPr id="23" name="Text 21"/>
+          <p:cNvSpPr/>
+          <p:nvPr/>
+        </p:nvSpPr>
+        <p:spPr>
+          <a:xfrm>
+            <a:off x="9893808" y="2926080"/>
+            <a:ext cx="1645920" cy="256032"/>
+          </a:xfrm>
+          <a:prstGeom prst="rect">
+            <a:avLst/>
+          </a:prstGeom>
+          <a:noFill/>
+          <a:ln/>
+        </p:spPr>
+        <p:txBody>
+          <a:bodyPr wrap="square" lIns="0" tIns="0" rIns="0" bIns="0" rtlCol="0" anchor="ctr"/>
+          <a:lstStyle/>
+          <a:p>
+            <a:pPr indent="0" marL="0">
+              <a:buNone/>
+            </a:pPr>
+            <a:r>
+              <a:rPr lang="en-US" sz="1100" dirty="0">
+                <a:solidFill>
+                  <a:srgbClr val="6E878E"/>
+                </a:solidFill>
+                <a:latin typeface="Calibri" pitchFamily="34" charset="0"/>
+                <a:ea typeface="Calibri" pitchFamily="34" charset="-122"/>
+                <a:cs typeface="Calibri" pitchFamily="34" charset="-120"/>
+              </a:rPr>
+              <a:t>click rate</a:t>
+            </a:r>
+            <a:endParaRPr lang="en-US" sz="1100" dirty="0"/>
+          </a:p>
+        </p:txBody>
+      </p:sp>
+      <p:sp>
+        <p:nvSpPr>
+          <p:cNvPr id="24" name="Text 22"/>
+          <p:cNvSpPr/>
+          <p:nvPr/>
+        </p:nvSpPr>
+        <p:spPr>
+          <a:xfrm>
+            <a:off x="6510528" y="3255264"/>
+            <a:ext cx="4809744" cy="402336"/>
+          </a:xfrm>
+          <a:prstGeom prst="rect">
+            <a:avLst/>
+          </a:prstGeom>
+          <a:noFill/>
+          <a:ln/>
+        </p:spPr>
+        <p:txBody>
+          <a:bodyPr wrap="square" lIns="0" tIns="0" rIns="0" bIns="0" rtlCol="0" anchor="ctr"/>
+          <a:lstStyle/>
+          <a:p>
+            <a:pPr indent="0" marL="0">
+              <a:buNone/>
+            </a:pPr>
+            <a:r>
+              <a:rPr lang="en-US" sz="1150" dirty="0">
+                <a:solidFill>
+                  <a:srgbClr val="33484F"/>
+                </a:solidFill>
+                <a:latin typeface="Calibri" pitchFamily="34" charset="0"/>
+                <a:ea typeface="Calibri" pitchFamily="34" charset="-122"/>
+                <a:cs typeface="Calibri" pitchFamily="34" charset="-120"/>
+              </a:rPr>
+              <a:t>Reached 0.6% of the base — but almost everyone who got it clicked.</a:t>
+            </a:r>
+            <a:endParaRPr lang="en-US" sz="1150" dirty="0"/>
+          </a:p>
+        </p:txBody>
+      </p:sp>
+      <p:graphicFrame>
+        <p:nvGraphicFramePr>
+          <p:cNvPr id="25" name="Chart 0" descr=""/>
+          <p:cNvGraphicFramePr/>
+          <p:nvPr/>
+        </p:nvGraphicFramePr>
+        <p:xfrm>
+          <a:off x="548640" y="3931920"/>
+          <a:ext cx="5394960" cy="2103120"/>
+        </p:xfrm>
+        <a:graphic xmlns:a="http://schemas.openxmlformats.org/drawingml/2006/main">
+          <a:graphicData uri="http://schemas.openxmlformats.org/drawingml/2006/chart">
+            <c:chart xmlns:c="http://schemas.openxmlformats.org/drawingml/2006/chart" r:id="rId1"/>
+          </a:graphicData>
+        </a:graphic>
+      </p:graphicFrame>
+      <p:sp>
+        <p:nvSpPr>
+          <p:cNvPr id="26" name="Shape 23"/>
+          <p:cNvSpPr/>
+          <p:nvPr/>
+        </p:nvSpPr>
+        <p:spPr>
+          <a:xfrm>
+            <a:off x="6217920" y="3931920"/>
+            <a:ext cx="5394960" cy="2103120"/>
+          </a:xfrm>
+          <a:prstGeom prst="roundRect">
+            <a:avLst>
+              <a:gd name="adj" fmla="val 4348"/>
+            </a:avLst>
+          </a:prstGeom>
+          <a:solidFill>
+            <a:srgbClr val="0C2B33"/>
+          </a:solidFill>
+          <a:ln w="12700">
+            <a:solidFill>
+              <a:srgbClr val="0C2B33"/>
+            </a:solidFill>
+            <a:prstDash val="solid"/>
+          </a:ln>
+          <a:effectLst>
+            <a:outerShdw sx="100000" sy="100000" kx="0" ky="0" algn="bl" rotWithShape="0" blurRad="127000" dist="25400" dir="5400000">
+              <a:srgbClr val="0C2B33">
+                <a:alpha val="10000"/>
+              </a:srgbClr>
+            </a:outerShdw>
+          </a:effectLst>
+        </p:spPr>
+      </p:sp>
+      <p:sp>
+        <p:nvSpPr>
+          <p:cNvPr id="27" name="Text 24"/>
+          <p:cNvSpPr/>
+          <p:nvPr/>
+        </p:nvSpPr>
+        <p:spPr>
+          <a:xfrm>
+            <a:off x="6537960" y="4169664"/>
+            <a:ext cx="4754880" cy="292608"/>
+          </a:xfrm>
+          <a:prstGeom prst="rect">
+            <a:avLst/>
+          </a:prstGeom>
+          <a:noFill/>
+          <a:ln/>
+        </p:spPr>
+        <p:txBody>
+          <a:bodyPr wrap="square" lIns="0" tIns="0" rIns="0" bIns="0" rtlCol="0" anchor="ctr"/>
+          <a:lstStyle/>
+          <a:p>
+            <a:pPr indent="0" marL="0">
+              <a:buNone/>
+            </a:pPr>
+            <a:r>
+              <a:rPr lang="en-US" sz="1300" b="1" dirty="0">
+                <a:solidFill>
+                  <a:srgbClr val="00A896"/>
+                </a:solidFill>
+                <a:latin typeface="Calibri" pitchFamily="34" charset="0"/>
+                <a:ea typeface="Calibri" pitchFamily="34" charset="-122"/>
+                <a:cs typeface="Calibri" pitchFamily="34" charset="-120"/>
+              </a:rPr>
+              <a:t>Scale is the gap, not quality</a:t>
+            </a:r>
+            <a:endParaRPr lang="en-US" sz="1300" dirty="0"/>
+          </a:p>
+        </p:txBody>
+      </p:sp>
+      <p:sp>
+        <p:nvSpPr>
+          <p:cNvPr id="28" name="Text 25"/>
+          <p:cNvSpPr/>
+          <p:nvPr/>
+        </p:nvSpPr>
+        <p:spPr>
+          <a:xfrm>
+            <a:off x="6537960" y="4517136"/>
+            <a:ext cx="4754880" cy="1005840"/>
+          </a:xfrm>
+          <a:prstGeom prst="rect">
+            <a:avLst/>
+          </a:prstGeom>
+          <a:noFill/>
+          <a:ln/>
+        </p:spPr>
+        <p:txBody>
+          <a:bodyPr wrap="square" lIns="0" tIns="0" rIns="0" bIns="0" rtlCol="0" anchor="ctr"/>
+          <a:lstStyle/>
+          <a:p>
+            <a:pPr indent="0" marL="0">
+              <a:lnSpc>
+                <a:spcPts val="1700"/>
+              </a:lnSpc>
+              <a:buNone/>
+            </a:pPr>
+            <a:r>
+              <a:rPr lang="en-US" sz="3200" b="1" dirty="0">
+                <a:solidFill>
+                  <a:srgbClr val="FFFFFF"/>
+                </a:solidFill>
+                <a:latin typeface="Cambria" pitchFamily="34" charset="0"/>
+                <a:ea typeface="Cambria" pitchFamily="34" charset="-122"/>
+                <a:cs typeface="Cambria" pitchFamily="34" charset="-120"/>
+              </a:rPr>
+              <a:t>143 : 1</a:t>
+            </a:r>
+            <a:endParaRPr lang="en-US" sz="3200" dirty="0"/>
+          </a:p>
+          <a:p>
+            <a:pPr indent="0" marL="0">
+              <a:lnSpc>
+                <a:spcPts val="1700"/>
+              </a:lnSpc>
+              <a:buNone/>
+            </a:pPr>
+            <a:r>
+              <a:rPr lang="en-US" sz="1250" dirty="0">
+                <a:solidFill>
+                  <a:srgbClr val="A9C9CE"/>
+                </a:solidFill>
+                <a:latin typeface="Calibri" pitchFamily="34" charset="0"/>
+                <a:ea typeface="Calibri" pitchFamily="34" charset="-122"/>
+                <a:cs typeface="Calibri" pitchFamily="34" charset="-120"/>
+              </a:rPr>
+              <a:t>banner viewers for every push recipient — while push converts at 2.2x the banner's rate.</a:t>
+            </a:r>
+            <a:endParaRPr lang="en-US" sz="3200" dirty="0"/>
+          </a:p>
+        </p:txBody>
+      </p:sp>
+      <p:sp>
+        <p:nvSpPr>
+          <p:cNvPr id="29" name="Text 26"/>
+          <p:cNvSpPr/>
+          <p:nvPr/>
+        </p:nvSpPr>
+        <p:spPr>
+          <a:xfrm>
+            <a:off x="6537960" y="5541264"/>
+            <a:ext cx="4754880" cy="274320"/>
+          </a:xfrm>
+          <a:prstGeom prst="rect">
+            <a:avLst/>
+          </a:prstGeom>
+          <a:noFill/>
+          <a:ln/>
+        </p:spPr>
+        <p:txBody>
+          <a:bodyPr wrap="square" lIns="0" tIns="0" rIns="0" bIns="0" rtlCol="0" anchor="ctr"/>
+          <a:lstStyle/>
+          <a:p>
+            <a:pPr indent="0" marL="0">
+              <a:buNone/>
+            </a:pPr>
+            <a:r>
+              <a:rPr lang="en-US" sz="1150" i="1" dirty="0">
+                <a:solidFill>
+                  <a:srgbClr val="8FB4BA"/>
+                </a:solidFill>
+                <a:latin typeface="Calibri" pitchFamily="34" charset="0"/>
+                <a:ea typeface="Calibri" pitchFamily="34" charset="-122"/>
+                <a:cs typeface="Calibri" pitchFamily="34" charset="-120"/>
+              </a:rPr>
+              <a:t>The overall 40.7% click rate is, in practice, the banner's number.</a:t>
+            </a:r>
+            <a:endParaRPr lang="en-US" sz="1150" dirty="0"/>
+          </a:p>
+        </p:txBody>
+      </p:sp>
+      <p:sp>
+        <p:nvSpPr>
+          <p:cNvPr id="30" name="Text 27"/>
+          <p:cNvSpPr/>
+          <p:nvPr/>
+        </p:nvSpPr>
+        <p:spPr>
+          <a:xfrm>
+            <a:off x="548640" y="6144768"/>
+            <a:ext cx="11064240" cy="310896"/>
+          </a:xfrm>
+          <a:prstGeom prst="rect">
+            <a:avLst/>
+          </a:prstGeom>
+          <a:noFill/>
+          <a:ln/>
+        </p:spPr>
+        <p:txBody>
+          <a:bodyPr wrap="square" lIns="0" tIns="0" rIns="0" bIns="0" rtlCol="0" anchor="ctr"/>
+          <a:lstStyle/>
+          <a:p>
+            <a:pPr indent="0" marL="0">
+              <a:buNone/>
+            </a:pPr>
+            <a:r>
+              <a:rPr lang="en-US" sz="1050" dirty="0">
+                <a:solidFill>
+                  <a:srgbClr val="6E878E"/>
+                </a:solidFill>
+                <a:latin typeface="Calibri" pitchFamily="34" charset="0"/>
+                <a:ea typeface="Calibri" pitchFamily="34" charset="-122"/>
+                <a:cs typeface="Calibri" pitchFamily="34" charset="-120"/>
+              </a:rPr>
+              <a:t>77 customers saw both channels and 11 clicked both, so channel figures sum to more than the 11,184 total viewers and 4,547 total clicks.</a:t>
+            </a:r>
+            <a:endParaRPr lang="en-US" sz="1050" dirty="0"/>
+          </a:p>
+        </p:txBody>
+      </p:sp>
+    </p:spTree>
+  </p:cSld>
+  <p:clrMapOvr>
+    <a:masterClrMapping/>
+  </p:clrMapOvr>
+</p:sld>
+</file>
+
+<file path=ppt/slides/slide7.xml><?xml version="1.0" encoding="utf-8"?>
+<p:sld xmlns:a="http://schemas.openxmlformats.org/drawingml/2006/main" xmlns:r="http://schemas.openxmlformats.org/officeDocument/2006/relationships" xmlns:p="http://schemas.openxmlformats.org/presentationml/2006/main">
+  <p:cSld name="Slide 7">
+    <p:bg>
+      <p:bgPr>
+        <a:solidFill>
+          <a:srgbClr val="FFFFFF"/>
+        </a:solidFill>
+      </p:bgPr>
+    </p:bg>
+    <p:spTree>
+      <p:nvGrpSpPr>
+        <p:cNvPr id="1" name=""/>
+        <p:cNvGrpSpPr/>
+        <p:nvPr/>
+      </p:nvGrpSpPr>
+      <p:grpSpPr>
+        <a:xfrm>
+          <a:off x="0" y="0"/>
+          <a:ext cx="0" cy="0"/>
+          <a:chOff x="0" y="0"/>
+          <a:chExt cx="0" cy="0"/>
+        </a:xfrm>
+      </p:grpSpPr>
+      <p:sp>
+        <p:nvSpPr>
+          <p:cNvPr id="2" name="Text 0"/>
+          <p:cNvSpPr/>
+          <p:nvPr/>
+        </p:nvSpPr>
+        <p:spPr>
+          <a:xfrm>
+            <a:off x="548640" y="384048"/>
+            <a:ext cx="8229600" cy="256032"/>
+          </a:xfrm>
+          <a:prstGeom prst="rect">
+            <a:avLst/>
+          </a:prstGeom>
+          <a:noFill/>
+          <a:ln/>
+        </p:spPr>
+        <p:txBody>
+          <a:bodyPr wrap="square" lIns="0" tIns="0" rIns="0" bIns="0" rtlCol="0" anchor="ctr"/>
+          <a:lstStyle/>
+          <a:p>
+            <a:pPr indent="0" marL="0">
+              <a:buNone/>
+            </a:pPr>
+            <a:r>
+              <a:rPr lang="en-US" sz="1150" b="1" spc="200" kern="0" dirty="0">
+                <a:solidFill>
+                  <a:srgbClr val="028090"/>
+                </a:solidFill>
+                <a:latin typeface="Calibri" pitchFamily="34" charset="0"/>
+                <a:ea typeface="Calibri" pitchFamily="34" charset="-122"/>
+                <a:cs typeface="Calibri" pitchFamily="34" charset="-120"/>
+              </a:rPr>
+              <a:t>PUSH IN DETAIL</a:t>
+            </a:r>
+            <a:endParaRPr lang="en-US" sz="1150" dirty="0"/>
+          </a:p>
+        </p:txBody>
+      </p:sp>
+      <p:sp>
+        <p:nvSpPr>
+          <p:cNvPr id="3" name="Text 1"/>
+          <p:cNvSpPr/>
+          <p:nvPr/>
+        </p:nvSpPr>
+        <p:spPr>
+          <a:xfrm>
+            <a:off x="548640" y="694944"/>
+            <a:ext cx="10607040" cy="658368"/>
+          </a:xfrm>
+          <a:prstGeom prst="rect">
+            <a:avLst/>
+          </a:prstGeom>
+          <a:noFill/>
+          <a:ln/>
+        </p:spPr>
+        <p:txBody>
+          <a:bodyPr wrap="square" lIns="0" tIns="0" rIns="0" bIns="0" rtlCol="0" anchor="ctr"/>
+          <a:lstStyle/>
+          <a:p>
+            <a:pPr indent="0" marL="0">
+              <a:buNone/>
+            </a:pPr>
+            <a:r>
+              <a:rPr lang="en-US" sz="3200" b="1" dirty="0">
+                <a:solidFill>
+                  <a:srgbClr val="0C2B33"/>
+                </a:solidFill>
+                <a:latin typeface="Cambria" pitchFamily="34" charset="0"/>
+                <a:ea typeface="Cambria" pitchFamily="34" charset="-122"/>
+                <a:cs typeface="Cambria" pitchFamily="34" charset="-120"/>
+              </a:rPr>
+              <a:t>Push rescued the clicks the banner lost</a:t>
+            </a:r>
+            <a:endParaRPr lang="en-US" sz="3200" dirty="0"/>
+          </a:p>
+        </p:txBody>
+      </p:sp>
+      <p:sp>
+        <p:nvSpPr>
+          <p:cNvPr id="4" name="Text 2"/>
+          <p:cNvSpPr/>
+          <p:nvPr/>
+        </p:nvSpPr>
+        <p:spPr>
+          <a:xfrm>
+            <a:off x="548640" y="1335024"/>
+            <a:ext cx="10607040" cy="310896"/>
+          </a:xfrm>
+          <a:prstGeom prst="rect">
+            <a:avLst/>
+          </a:prstGeom>
+          <a:noFill/>
+          <a:ln/>
+        </p:spPr>
+        <p:txBody>
+          <a:bodyPr wrap="square" lIns="0" tIns="0" rIns="0" bIns="0" rtlCol="0" anchor="ctr"/>
+          <a:lstStyle/>
+          <a:p>
+            <a:pPr indent="0" marL="0">
+              <a:buNone/>
+            </a:pPr>
+            <a:r>
+              <a:rPr lang="en-US" sz="1400" dirty="0">
+                <a:solidFill>
+                  <a:srgbClr val="6E878E"/>
+                </a:solidFill>
+                <a:latin typeface="Calibri" pitchFamily="34" charset="0"/>
+                <a:ea typeface="Calibri" pitchFamily="34" charset="-122"/>
+                <a:cs typeface="Calibri" pitchFamily="34" charset="-120"/>
+              </a:rPr>
+              <a:t>Push went only to Existing with Save Max — 78 of that segment's 6,765 customers.</a:t>
+            </a:r>
+            <a:endParaRPr lang="en-US" sz="1400" dirty="0"/>
+          </a:p>
+        </p:txBody>
+      </p:sp>
+      <p:sp>
+        <p:nvSpPr>
+          <p:cNvPr id="5" name="Shape 3"/>
+          <p:cNvSpPr/>
+          <p:nvPr/>
+        </p:nvSpPr>
+        <p:spPr>
+          <a:xfrm>
+            <a:off x="548640" y="1783080"/>
+            <a:ext cx="2423160" cy="1051560"/>
+          </a:xfrm>
+          <a:prstGeom prst="roundRect">
+            <a:avLst>
+              <a:gd name="adj" fmla="val 7826"/>
+            </a:avLst>
+          </a:prstGeom>
+          <a:solidFill>
+            <a:srgbClr val="0C2B33"/>
+          </a:solidFill>
+          <a:ln w="12700">
+            <a:solidFill>
+              <a:srgbClr val="0C2B33"/>
+            </a:solidFill>
+            <a:prstDash val="solid"/>
+          </a:ln>
+        </p:spPr>
+      </p:sp>
+      <p:sp>
+        <p:nvSpPr>
+          <p:cNvPr id="6" name="Text 4"/>
+          <p:cNvSpPr/>
+          <p:nvPr/>
+        </p:nvSpPr>
+        <p:spPr>
+          <a:xfrm>
+            <a:off x="731520" y="1883664"/>
+            <a:ext cx="2057400" cy="475488"/>
+          </a:xfrm>
+          <a:prstGeom prst="rect">
+            <a:avLst/>
+          </a:prstGeom>
+          <a:noFill/>
+          <a:ln/>
+        </p:spPr>
+        <p:txBody>
+          <a:bodyPr wrap="square" lIns="0" tIns="0" rIns="0" bIns="0" rtlCol="0" anchor="ctr"/>
+          <a:lstStyle/>
+          <a:p>
+            <a:pPr indent="0" marL="0">
+              <a:buNone/>
+            </a:pPr>
+            <a:r>
+              <a:rPr lang="en-US" sz="2500" b="1" dirty="0">
+                <a:solidFill>
+                  <a:srgbClr val="FFFFFF"/>
+                </a:solidFill>
+                <a:latin typeface="Cambria" pitchFamily="34" charset="0"/>
+                <a:ea typeface="Cambria" pitchFamily="34" charset="-122"/>
+                <a:cs typeface="Cambria" pitchFamily="34" charset="-120"/>
+              </a:rPr>
+              <a:t>6,765</a:t>
+            </a:r>
+            <a:endParaRPr lang="en-US" sz="2500" dirty="0"/>
+          </a:p>
+        </p:txBody>
+      </p:sp>
+      <p:sp>
+        <p:nvSpPr>
+          <p:cNvPr id="7" name="Text 5"/>
+          <p:cNvSpPr/>
+          <p:nvPr/>
+        </p:nvSpPr>
+        <p:spPr>
+          <a:xfrm>
+            <a:off x="731520" y="2340864"/>
+            <a:ext cx="2057400" cy="292608"/>
+          </a:xfrm>
+          <a:prstGeom prst="rect">
+            <a:avLst/>
+          </a:prstGeom>
+          <a:noFill/>
+          <a:ln/>
+        </p:spPr>
+        <p:txBody>
+          <a:bodyPr wrap="square" lIns="0" tIns="0" rIns="0" bIns="0" rtlCol="0" anchor="ctr"/>
+          <a:lstStyle/>
+          <a:p>
+            <a:pPr indent="0" marL="0">
+              <a:buNone/>
+            </a:pPr>
+            <a:r>
+              <a:rPr lang="en-US" sz="1150" dirty="0">
+                <a:solidFill>
+                  <a:srgbClr val="A9C9CE"/>
+                </a:solidFill>
+                <a:latin typeface="Calibri" pitchFamily="34" charset="0"/>
+                <a:ea typeface="Calibri" pitchFamily="34" charset="-122"/>
+                <a:cs typeface="Calibri" pitchFamily="34" charset="-120"/>
+              </a:rPr>
+              <a:t>Save Max base</a:t>
+            </a:r>
+            <a:endParaRPr lang="en-US" sz="1150" dirty="0"/>
+          </a:p>
+        </p:txBody>
+      </p:sp>
+      <p:sp>
+        <p:nvSpPr>
+          <p:cNvPr id="8" name="Text 6"/>
+          <p:cNvSpPr/>
+          <p:nvPr/>
+        </p:nvSpPr>
+        <p:spPr>
+          <a:xfrm>
+            <a:off x="2971800" y="1783080"/>
+            <a:ext cx="457200" cy="1051560"/>
+          </a:xfrm>
+          <a:prstGeom prst="rect">
+            <a:avLst/>
+          </a:prstGeom>
+          <a:noFill/>
+          <a:ln/>
+        </p:spPr>
+        <p:txBody>
+          <a:bodyPr wrap="square" lIns="0" tIns="0" rIns="0" bIns="0" rtlCol="0" anchor="ctr"/>
+          <a:lstStyle/>
+          <a:p>
+            <a:pPr algn="ctr" indent="0" marL="0">
+              <a:buNone/>
+            </a:pPr>
+            <a:r>
+              <a:rPr lang="en-US" sz="2000" b="1" dirty="0">
+                <a:solidFill>
+                  <a:srgbClr val="7E9AA1"/>
+                </a:solidFill>
+                <a:latin typeface="Calibri" pitchFamily="34" charset="0"/>
+                <a:ea typeface="Calibri" pitchFamily="34" charset="-122"/>
+                <a:cs typeface="Calibri" pitchFamily="34" charset="-120"/>
+              </a:rPr>
+              <a:t>→</a:t>
+            </a:r>
+            <a:endParaRPr lang="en-US" sz="2000" dirty="0"/>
+          </a:p>
+        </p:txBody>
+      </p:sp>
+      <p:sp>
+        <p:nvSpPr>
+          <p:cNvPr id="9" name="Shape 7"/>
+          <p:cNvSpPr/>
+          <p:nvPr/>
+        </p:nvSpPr>
+        <p:spPr>
+          <a:xfrm>
+            <a:off x="3429000" y="1783080"/>
+            <a:ext cx="2423160" cy="1051560"/>
+          </a:xfrm>
+          <a:prstGeom prst="roundRect">
+            <a:avLst>
+              <a:gd name="adj" fmla="val 7826"/>
+            </a:avLst>
+          </a:prstGeom>
+          <a:solidFill>
+            <a:srgbClr val="028090"/>
+          </a:solidFill>
+          <a:ln w="12700">
+            <a:solidFill>
+              <a:srgbClr val="028090"/>
+            </a:solidFill>
+            <a:prstDash val="solid"/>
+          </a:ln>
+        </p:spPr>
+      </p:sp>
+      <p:sp>
+        <p:nvSpPr>
+          <p:cNvPr id="10" name="Text 8"/>
+          <p:cNvSpPr/>
+          <p:nvPr/>
+        </p:nvSpPr>
+        <p:spPr>
+          <a:xfrm>
+            <a:off x="3611880" y="1883664"/>
+            <a:ext cx="2057400" cy="475488"/>
+          </a:xfrm>
+          <a:prstGeom prst="rect">
+            <a:avLst/>
+          </a:prstGeom>
+          <a:noFill/>
+          <a:ln/>
+        </p:spPr>
+        <p:txBody>
+          <a:bodyPr wrap="square" lIns="0" tIns="0" rIns="0" bIns="0" rtlCol="0" anchor="ctr"/>
+          <a:lstStyle/>
+          <a:p>
+            <a:pPr indent="0" marL="0">
+              <a:buNone/>
+            </a:pPr>
+            <a:r>
+              <a:rPr lang="en-US" sz="2500" b="1" dirty="0">
+                <a:solidFill>
+                  <a:srgbClr val="FFFFFF"/>
+                </a:solidFill>
+                <a:latin typeface="Cambria" pitchFamily="34" charset="0"/>
+                <a:ea typeface="Cambria" pitchFamily="34" charset="-122"/>
+                <a:cs typeface="Cambria" pitchFamily="34" charset="-120"/>
+              </a:rPr>
+              <a:t>5,925</a:t>
+            </a:r>
+            <a:endParaRPr lang="en-US" sz="2500" dirty="0"/>
+          </a:p>
+        </p:txBody>
+      </p:sp>
+      <p:sp>
+        <p:nvSpPr>
+          <p:cNvPr id="11" name="Text 9"/>
+          <p:cNvSpPr/>
+          <p:nvPr/>
+        </p:nvSpPr>
+        <p:spPr>
+          <a:xfrm>
+            <a:off x="3611880" y="2340864"/>
+            <a:ext cx="2057400" cy="292608"/>
+          </a:xfrm>
+          <a:prstGeom prst="rect">
+            <a:avLst/>
+          </a:prstGeom>
+          <a:noFill/>
+          <a:ln/>
+        </p:spPr>
+        <p:txBody>
+          <a:bodyPr wrap="square" lIns="0" tIns="0" rIns="0" bIns="0" rtlCol="0" anchor="ctr"/>
+          <a:lstStyle/>
+          <a:p>
+            <a:pPr indent="0" marL="0">
+              <a:buNone/>
+            </a:pPr>
+            <a:r>
+              <a:rPr lang="en-US" sz="1150" dirty="0">
+                <a:solidFill>
+                  <a:srgbClr val="A9C9CE"/>
+                </a:solidFill>
+                <a:latin typeface="Calibri" pitchFamily="34" charset="0"/>
+                <a:ea typeface="Calibri" pitchFamily="34" charset="-122"/>
+                <a:cs typeface="Calibri" pitchFamily="34" charset="-120"/>
+              </a:rPr>
+              <a:t>saw the banner</a:t>
+            </a:r>
+            <a:endParaRPr lang="en-US" sz="1150" dirty="0"/>
+          </a:p>
+        </p:txBody>
+      </p:sp>
+      <p:sp>
+        <p:nvSpPr>
+          <p:cNvPr id="12" name="Text 10"/>
+          <p:cNvSpPr/>
+          <p:nvPr/>
+        </p:nvSpPr>
+        <p:spPr>
+          <a:xfrm>
+            <a:off x="5852160" y="1783080"/>
+            <a:ext cx="457200" cy="1051560"/>
+          </a:xfrm>
+          <a:prstGeom prst="rect">
+            <a:avLst/>
+          </a:prstGeom>
+          <a:noFill/>
+          <a:ln/>
+        </p:spPr>
+        <p:txBody>
+          <a:bodyPr wrap="square" lIns="0" tIns="0" rIns="0" bIns="0" rtlCol="0" anchor="ctr"/>
+          <a:lstStyle/>
+          <a:p>
+            <a:pPr algn="ctr" indent="0" marL="0">
+              <a:buNone/>
+            </a:pPr>
+            <a:r>
+              <a:rPr lang="en-US" sz="2000" b="1" dirty="0">
+                <a:solidFill>
+                  <a:srgbClr val="7E9AA1"/>
+                </a:solidFill>
+                <a:latin typeface="Calibri" pitchFamily="34" charset="0"/>
+                <a:ea typeface="Calibri" pitchFamily="34" charset="-122"/>
+                <a:cs typeface="Calibri" pitchFamily="34" charset="-120"/>
+              </a:rPr>
+              <a:t>→</a:t>
+            </a:r>
+            <a:endParaRPr lang="en-US" sz="2000" dirty="0"/>
+          </a:p>
+        </p:txBody>
+      </p:sp>
+      <p:sp>
+        <p:nvSpPr>
+          <p:cNvPr id="13" name="Shape 11"/>
+          <p:cNvSpPr/>
+          <p:nvPr/>
+        </p:nvSpPr>
+        <p:spPr>
+          <a:xfrm>
+            <a:off x="6309360" y="1783080"/>
+            <a:ext cx="2423160" cy="1051560"/>
+          </a:xfrm>
+          <a:prstGeom prst="roundRect">
+            <a:avLst>
+              <a:gd name="adj" fmla="val 7826"/>
+            </a:avLst>
+          </a:prstGeom>
+          <a:solidFill>
+            <a:srgbClr val="00A896"/>
+          </a:solidFill>
+          <a:ln w="12700">
+            <a:solidFill>
+              <a:srgbClr val="00A896"/>
+            </a:solidFill>
+            <a:prstDash val="solid"/>
+          </a:ln>
+        </p:spPr>
+      </p:sp>
+      <p:sp>
+        <p:nvSpPr>
+          <p:cNvPr id="14" name="Text 12"/>
+          <p:cNvSpPr/>
+          <p:nvPr/>
+        </p:nvSpPr>
+        <p:spPr>
+          <a:xfrm>
+            <a:off x="6492240" y="1883664"/>
+            <a:ext cx="2057400" cy="475488"/>
+          </a:xfrm>
+          <a:prstGeom prst="rect">
+            <a:avLst/>
+          </a:prstGeom>
+          <a:noFill/>
+          <a:ln/>
+        </p:spPr>
+        <p:txBody>
+          <a:bodyPr wrap="square" lIns="0" tIns="0" rIns="0" bIns="0" rtlCol="0" anchor="ctr"/>
+          <a:lstStyle/>
+          <a:p>
+            <a:pPr indent="0" marL="0">
+              <a:buNone/>
+            </a:pPr>
+            <a:r>
+              <a:rPr lang="en-US" sz="2500" b="1" dirty="0">
+                <a:solidFill>
+                  <a:srgbClr val="0C2B33"/>
+                </a:solidFill>
+                <a:latin typeface="Cambria" pitchFamily="34" charset="0"/>
+                <a:ea typeface="Cambria" pitchFamily="34" charset="-122"/>
+                <a:cs typeface="Cambria" pitchFamily="34" charset="-120"/>
+              </a:rPr>
+              <a:t>78</a:t>
+            </a:r>
+            <a:endParaRPr lang="en-US" sz="2500" dirty="0"/>
+          </a:p>
+        </p:txBody>
+      </p:sp>
+      <p:sp>
+        <p:nvSpPr>
+          <p:cNvPr id="15" name="Text 13"/>
+          <p:cNvSpPr/>
+          <p:nvPr/>
+        </p:nvSpPr>
+        <p:spPr>
+          <a:xfrm>
+            <a:off x="6492240" y="2340864"/>
+            <a:ext cx="2057400" cy="292608"/>
+          </a:xfrm>
+          <a:prstGeom prst="rect">
+            <a:avLst/>
+          </a:prstGeom>
+          <a:noFill/>
+          <a:ln/>
+        </p:spPr>
+        <p:txBody>
+          <a:bodyPr wrap="square" lIns="0" tIns="0" rIns="0" bIns="0" rtlCol="0" anchor="ctr"/>
+          <a:lstStyle/>
+          <a:p>
+            <a:pPr indent="0" marL="0">
+              <a:buNone/>
+            </a:pPr>
+            <a:r>
+              <a:rPr lang="en-US" sz="1150" dirty="0">
+                <a:solidFill>
+                  <a:srgbClr val="0A3B42"/>
+                </a:solidFill>
+                <a:latin typeface="Calibri" pitchFamily="34" charset="0"/>
+                <a:ea typeface="Calibri" pitchFamily="34" charset="-122"/>
+                <a:cs typeface="Calibri" pitchFamily="34" charset="-120"/>
+              </a:rPr>
+              <a:t>also got push</a:t>
+            </a:r>
+            <a:endParaRPr lang="en-US" sz="1150" dirty="0"/>
+          </a:p>
+        </p:txBody>
+      </p:sp>
+      <p:sp>
+        <p:nvSpPr>
+          <p:cNvPr id="16" name="Text 14"/>
+          <p:cNvSpPr/>
+          <p:nvPr/>
+        </p:nvSpPr>
+        <p:spPr>
+          <a:xfrm>
+            <a:off x="8732520" y="1783080"/>
+            <a:ext cx="457200" cy="1051560"/>
+          </a:xfrm>
+          <a:prstGeom prst="rect">
+            <a:avLst/>
+          </a:prstGeom>
+          <a:noFill/>
+          <a:ln/>
+        </p:spPr>
+        <p:txBody>
+          <a:bodyPr wrap="square" lIns="0" tIns="0" rIns="0" bIns="0" rtlCol="0" anchor="ctr"/>
+          <a:lstStyle/>
+          <a:p>
+            <a:pPr algn="ctr" indent="0" marL="0">
+              <a:buNone/>
+            </a:pPr>
+            <a:r>
+              <a:rPr lang="en-US" sz="2000" b="1" dirty="0">
+                <a:solidFill>
+                  <a:srgbClr val="7E9AA1"/>
+                </a:solidFill>
+                <a:latin typeface="Calibri" pitchFamily="34" charset="0"/>
+                <a:ea typeface="Calibri" pitchFamily="34" charset="-122"/>
+                <a:cs typeface="Calibri" pitchFamily="34" charset="-120"/>
+              </a:rPr>
+              <a:t>→</a:t>
+            </a:r>
+            <a:endParaRPr lang="en-US" sz="2000" dirty="0"/>
+          </a:p>
+        </p:txBody>
+      </p:sp>
+      <p:sp>
+        <p:nvSpPr>
+          <p:cNvPr id="17" name="Shape 15"/>
+          <p:cNvSpPr/>
+          <p:nvPr/>
+        </p:nvSpPr>
+        <p:spPr>
+          <a:xfrm>
+            <a:off x="9189720" y="1783080"/>
+            <a:ext cx="2423160" cy="1051560"/>
+          </a:xfrm>
+          <a:prstGeom prst="roundRect">
+            <a:avLst>
+              <a:gd name="adj" fmla="val 7826"/>
+            </a:avLst>
+          </a:prstGeom>
+          <a:solidFill>
+            <a:srgbClr val="02C39A"/>
+          </a:solidFill>
+          <a:ln w="12700">
+            <a:solidFill>
+              <a:srgbClr val="02C39A"/>
+            </a:solidFill>
+            <a:prstDash val="solid"/>
+          </a:ln>
+        </p:spPr>
+      </p:sp>
+      <p:sp>
+        <p:nvSpPr>
+          <p:cNvPr id="18" name="Text 16"/>
+          <p:cNvSpPr/>
+          <p:nvPr/>
+        </p:nvSpPr>
+        <p:spPr>
+          <a:xfrm>
+            <a:off x="9372600" y="1883664"/>
+            <a:ext cx="2057400" cy="475488"/>
+          </a:xfrm>
+          <a:prstGeom prst="rect">
+            <a:avLst/>
+          </a:prstGeom>
+          <a:noFill/>
+          <a:ln/>
+        </p:spPr>
+        <p:txBody>
+          <a:bodyPr wrap="square" lIns="0" tIns="0" rIns="0" bIns="0" rtlCol="0" anchor="ctr"/>
+          <a:lstStyle/>
+          <a:p>
+            <a:pPr indent="0" marL="0">
+              <a:buNone/>
+            </a:pPr>
+            <a:r>
+              <a:rPr lang="en-US" sz="2500" b="1" dirty="0">
+                <a:solidFill>
+                  <a:srgbClr val="0C2B33"/>
+                </a:solidFill>
+                <a:latin typeface="Cambria" pitchFamily="34" charset="0"/>
+                <a:ea typeface="Cambria" pitchFamily="34" charset="-122"/>
+                <a:cs typeface="Cambria" pitchFamily="34" charset="-120"/>
+              </a:rPr>
+              <a:t>68</a:t>
+            </a:r>
+            <a:endParaRPr lang="en-US" sz="2500" dirty="0"/>
+          </a:p>
+        </p:txBody>
+      </p:sp>
+      <p:sp>
+        <p:nvSpPr>
+          <p:cNvPr id="19" name="Text 17"/>
+          <p:cNvSpPr/>
+          <p:nvPr/>
+        </p:nvSpPr>
+        <p:spPr>
+          <a:xfrm>
+            <a:off x="9372600" y="2340864"/>
+            <a:ext cx="2057400" cy="292608"/>
+          </a:xfrm>
+          <a:prstGeom prst="rect">
+            <a:avLst/>
+          </a:prstGeom>
+          <a:noFill/>
+          <a:ln/>
+        </p:spPr>
+        <p:txBody>
+          <a:bodyPr wrap="square" lIns="0" tIns="0" rIns="0" bIns="0" rtlCol="0" anchor="ctr"/>
+          <a:lstStyle/>
+          <a:p>
+            <a:pPr indent="0" marL="0">
+              <a:buNone/>
+            </a:pPr>
+            <a:r>
+              <a:rPr lang="en-US" sz="1150" dirty="0">
+                <a:solidFill>
+                  <a:srgbClr val="0A3B42"/>
+                </a:solidFill>
+                <a:latin typeface="Calibri" pitchFamily="34" charset="0"/>
+                <a:ea typeface="Calibri" pitchFamily="34" charset="-122"/>
+                <a:cs typeface="Calibri" pitchFamily="34" charset="-120"/>
+              </a:rPr>
+              <a:t>clicked the push</a:t>
+            </a:r>
+            <a:endParaRPr lang="en-US" sz="1150" dirty="0"/>
+          </a:p>
+        </p:txBody>
+      </p:sp>
+      <p:sp>
+        <p:nvSpPr>
+          <p:cNvPr id="20" name="Shape 18"/>
+          <p:cNvSpPr/>
+          <p:nvPr/>
+        </p:nvSpPr>
+        <p:spPr>
+          <a:xfrm>
+            <a:off x="548640" y="3063240"/>
+            <a:ext cx="5394960" cy="1737360"/>
+          </a:xfrm>
+          <a:prstGeom prst="roundRect">
+            <a:avLst>
+              <a:gd name="adj" fmla="val 5263"/>
+            </a:avLst>
+          </a:prstGeom>
+          <a:solidFill>
+            <a:srgbClr val="EEF5F5"/>
+          </a:solidFill>
+          <a:ln w="12700">
+            <a:solidFill>
+              <a:srgbClr val="DDE9E9"/>
+            </a:solidFill>
+            <a:prstDash val="solid"/>
+          </a:ln>
+          <a:effectLst>
+            <a:outerShdw sx="100000" sy="100000" kx="0" ky="0" algn="bl" rotWithShape="0" blurRad="127000" dist="25400" dir="5400000">
+              <a:srgbClr val="0C2B33">
+                <a:alpha val="10000"/>
+              </a:srgbClr>
+            </a:outerShdw>
+          </a:effectLst>
+        </p:spPr>
+      </p:sp>
+      <p:sp>
+        <p:nvSpPr>
+          <p:cNvPr id="21" name="Text 19"/>
+          <p:cNvSpPr/>
+          <p:nvPr/>
+        </p:nvSpPr>
+        <p:spPr>
+          <a:xfrm>
+            <a:off x="841248" y="3246120"/>
+            <a:ext cx="1600200" cy="566928"/>
+          </a:xfrm>
+          <a:prstGeom prst="rect">
+            <a:avLst/>
+          </a:prstGeom>
+          <a:noFill/>
+          <a:ln/>
+        </p:spPr>
+        <p:txBody>
+          <a:bodyPr wrap="square" lIns="0" tIns="0" rIns="0" bIns="0" rtlCol="0" anchor="ctr"/>
+          <a:lstStyle/>
+          <a:p>
+            <a:pPr indent="0" marL="0">
+              <a:buNone/>
+            </a:pPr>
+            <a:r>
+              <a:rPr lang="en-US" sz="3000" b="1" dirty="0">
+                <a:solidFill>
+                  <a:srgbClr val="028090"/>
+                </a:solidFill>
+                <a:latin typeface="Cambria" pitchFamily="34" charset="0"/>
+                <a:ea typeface="Cambria" pitchFamily="34" charset="-122"/>
+                <a:cs typeface="Cambria" pitchFamily="34" charset="-120"/>
+              </a:rPr>
+              <a:t>89.1%</a:t>
+            </a:r>
+            <a:endParaRPr lang="en-US" sz="3000" dirty="0"/>
+          </a:p>
+        </p:txBody>
+      </p:sp>
+      <p:sp>
+        <p:nvSpPr>
+          <p:cNvPr id="22" name="Text 20"/>
+          <p:cNvSpPr/>
+          <p:nvPr/>
+        </p:nvSpPr>
+        <p:spPr>
+          <a:xfrm>
+            <a:off x="2423160" y="3246120"/>
+            <a:ext cx="3227832" cy="566928"/>
+          </a:xfrm>
+          <a:prstGeom prst="rect">
+            <a:avLst/>
+          </a:prstGeom>
+          <a:noFill/>
+          <a:ln/>
+        </p:spPr>
+        <p:txBody>
+          <a:bodyPr wrap="square" lIns="0" tIns="0" rIns="0" bIns="0" rtlCol="0" anchor="ctr"/>
+          <a:lstStyle/>
+          <a:p>
+            <a:pPr indent="0" marL="0">
+              <a:buNone/>
+            </a:pPr>
+            <a:r>
+              <a:rPr lang="en-US" sz="1250" b="1" dirty="0">
+                <a:solidFill>
+                  <a:srgbClr val="0C2B33"/>
+                </a:solidFill>
+                <a:latin typeface="Calibri" pitchFamily="34" charset="0"/>
+                <a:ea typeface="Calibri" pitchFamily="34" charset="-122"/>
+                <a:cs typeface="Calibri" pitchFamily="34" charset="-120"/>
+              </a:rPr>
+              <a:t>of eligible recipients were rescued</a:t>
+            </a:r>
+            <a:endParaRPr lang="en-US" sz="1250" dirty="0"/>
+          </a:p>
+        </p:txBody>
+      </p:sp>
+      <p:sp>
+        <p:nvSpPr>
+          <p:cNvPr id="23" name="Text 21"/>
+          <p:cNvSpPr/>
+          <p:nvPr/>
+        </p:nvSpPr>
+        <p:spPr>
+          <a:xfrm>
+            <a:off x="841248" y="3886200"/>
+            <a:ext cx="4809744" cy="777240"/>
+          </a:xfrm>
+          <a:prstGeom prst="rect">
+            <a:avLst/>
+          </a:prstGeom>
+          <a:noFill/>
+          <a:ln/>
+        </p:spPr>
+        <p:txBody>
+          <a:bodyPr wrap="square" lIns="0" tIns="0" rIns="0" bIns="0" rtlCol="0" anchor="ctr"/>
+          <a:lstStyle/>
+          <a:p>
+            <a:pPr indent="0" marL="0">
+              <a:lnSpc>
+                <a:spcPts val="1500"/>
+              </a:lnSpc>
+              <a:buNone/>
+            </a:pPr>
+            <a:r>
+              <a:rPr lang="en-US" sz="1150" dirty="0">
+                <a:solidFill>
+                  <a:srgbClr val="33484F"/>
+                </a:solidFill>
+                <a:latin typeface="Calibri" pitchFamily="34" charset="0"/>
+                <a:ea typeface="Calibri" pitchFamily="34" charset="-122"/>
+                <a:cs typeface="Calibri" pitchFamily="34" charset="-120"/>
+              </a:rPr>
+              <a:t>64 push recipients had already seen the banner and not clicked it. 57 of them clicked the push — clicks the banner had failed to convert.</a:t>
+            </a:r>
+            <a:endParaRPr lang="en-US" sz="1150" dirty="0"/>
+          </a:p>
+        </p:txBody>
+      </p:sp>
+      <p:sp>
+        <p:nvSpPr>
+          <p:cNvPr id="24" name="Shape 22"/>
+          <p:cNvSpPr/>
+          <p:nvPr/>
+        </p:nvSpPr>
+        <p:spPr>
+          <a:xfrm>
+            <a:off x="6217920" y="3063240"/>
+            <a:ext cx="5394960" cy="1737360"/>
+          </a:xfrm>
+          <a:prstGeom prst="roundRect">
+            <a:avLst>
+              <a:gd name="adj" fmla="val 5263"/>
+            </a:avLst>
+          </a:prstGeom>
+          <a:solidFill>
+            <a:srgbClr val="EEF5F5"/>
+          </a:solidFill>
+          <a:ln w="12700">
+            <a:solidFill>
+              <a:srgbClr val="DDE9E9"/>
+            </a:solidFill>
+            <a:prstDash val="solid"/>
+          </a:ln>
+          <a:effectLst>
+            <a:outerShdw sx="100000" sy="100000" kx="0" ky="0" algn="bl" rotWithShape="0" blurRad="127000" dist="25400" dir="5400000">
+              <a:srgbClr val="0C2B33">
+                <a:alpha val="10000"/>
+              </a:srgbClr>
+            </a:outerShdw>
+          </a:effectLst>
+        </p:spPr>
+      </p:sp>
+      <p:sp>
+        <p:nvSpPr>
+          <p:cNvPr id="25" name="Text 23"/>
+          <p:cNvSpPr/>
+          <p:nvPr/>
+        </p:nvSpPr>
+        <p:spPr>
+          <a:xfrm>
+            <a:off x="6510528" y="3246120"/>
+            <a:ext cx="1600200" cy="566928"/>
+          </a:xfrm>
+          <a:prstGeom prst="rect">
+            <a:avLst/>
+          </a:prstGeom>
+          <a:noFill/>
+          <a:ln/>
+        </p:spPr>
+        <p:txBody>
+          <a:bodyPr wrap="square" lIns="0" tIns="0" rIns="0" bIns="0" rtlCol="0" anchor="ctr"/>
+          <a:lstStyle/>
+          <a:p>
+            <a:pPr indent="0" marL="0">
+              <a:buNone/>
+            </a:pPr>
+            <a:r>
+              <a:rPr lang="en-US" sz="3000" b="1" dirty="0">
+                <a:solidFill>
+                  <a:srgbClr val="028090"/>
+                </a:solidFill>
+                <a:latin typeface="Cambria" pitchFamily="34" charset="0"/>
+                <a:ea typeface="Cambria" pitchFamily="34" charset="-122"/>
+                <a:cs typeface="Cambria" pitchFamily="34" charset="-120"/>
+              </a:rPr>
+              <a:t>2.8x</a:t>
+            </a:r>
+            <a:endParaRPr lang="en-US" sz="3000" dirty="0"/>
+          </a:p>
+        </p:txBody>
+      </p:sp>
+      <p:sp>
+        <p:nvSpPr>
+          <p:cNvPr id="26" name="Text 24"/>
+          <p:cNvSpPr/>
+          <p:nvPr/>
+        </p:nvSpPr>
+        <p:spPr>
+          <a:xfrm>
+            <a:off x="8092440" y="3246120"/>
+            <a:ext cx="3227832" cy="566928"/>
+          </a:xfrm>
+          <a:prstGeom prst="rect">
+            <a:avLst/>
+          </a:prstGeom>
+          <a:noFill/>
+          <a:ln/>
+        </p:spPr>
+        <p:txBody>
+          <a:bodyPr wrap="square" lIns="0" tIns="0" rIns="0" bIns="0" rtlCol="0" anchor="ctr"/>
+          <a:lstStyle/>
+          <a:p>
+            <a:pPr indent="0" marL="0">
+              <a:buNone/>
+            </a:pPr>
+            <a:r>
+              <a:rPr lang="en-US" sz="1250" b="1" dirty="0">
+                <a:solidFill>
+                  <a:srgbClr val="0C2B33"/>
+                </a:solidFill>
+                <a:latin typeface="Calibri" pitchFamily="34" charset="0"/>
+                <a:ea typeface="Calibri" pitchFamily="34" charset="-122"/>
+                <a:cs typeface="Calibri" pitchFamily="34" charset="-120"/>
+              </a:rPr>
+              <a:t>the response, same customers</a:t>
+            </a:r>
+            <a:endParaRPr lang="en-US" sz="1250" dirty="0"/>
+          </a:p>
+        </p:txBody>
+      </p:sp>
+      <p:sp>
+        <p:nvSpPr>
+          <p:cNvPr id="27" name="Text 25"/>
+          <p:cNvSpPr/>
+          <p:nvPr/>
+        </p:nvSpPr>
+        <p:spPr>
+          <a:xfrm>
+            <a:off x="6510528" y="3886200"/>
+            <a:ext cx="4809744" cy="777240"/>
+          </a:xfrm>
+          <a:prstGeom prst="rect">
+            <a:avLst/>
+          </a:prstGeom>
+          <a:noFill/>
+          <a:ln/>
+        </p:spPr>
+        <p:txBody>
+          <a:bodyPr wrap="square" lIns="0" tIns="0" rIns="0" bIns="0" rtlCol="0" anchor="ctr"/>
+          <a:lstStyle/>
+          <a:p>
+            <a:pPr indent="0" marL="0">
+              <a:lnSpc>
+                <a:spcPts val="1500"/>
+              </a:lnSpc>
+              <a:buNone/>
+            </a:pPr>
+            <a:r>
+              <a:rPr lang="en-US" sz="1150" dirty="0">
+                <a:solidFill>
+                  <a:srgbClr val="33484F"/>
+                </a:solidFill>
+                <a:latin typeface="Calibri" pitchFamily="34" charset="0"/>
+                <a:ea typeface="Calibri" pitchFamily="34" charset="-122"/>
+                <a:cs typeface="Calibri" pitchFamily="34" charset="-120"/>
+              </a:rPr>
+              <a:t>Within Existing with Save Max: 30.9% click rate on banner, 87.2% on push. The audience is identical, so channel explains the gap.</a:t>
+            </a:r>
+            <a:endParaRPr lang="en-US" sz="1150" dirty="0"/>
+          </a:p>
+        </p:txBody>
+      </p:sp>
+      <p:sp>
+        <p:nvSpPr>
+          <p:cNvPr id="28" name="Shape 26"/>
+          <p:cNvSpPr/>
+          <p:nvPr/>
+        </p:nvSpPr>
+        <p:spPr>
+          <a:xfrm>
+            <a:off x="548640" y="4983480"/>
+            <a:ext cx="11064240" cy="868680"/>
+          </a:xfrm>
+          <a:prstGeom prst="roundRect">
+            <a:avLst>
+              <a:gd name="adj" fmla="val 10526"/>
+            </a:avLst>
+          </a:prstGeom>
+          <a:solidFill>
+            <a:srgbClr val="0C2B33"/>
+          </a:solidFill>
+          <a:ln w="12700">
+            <a:solidFill>
+              <a:srgbClr val="0C2B33"/>
+            </a:solidFill>
+            <a:prstDash val="solid"/>
+          </a:ln>
+          <a:effectLst>
+            <a:outerShdw sx="100000" sy="100000" kx="0" ky="0" algn="bl" rotWithShape="0" blurRad="127000" dist="25400" dir="5400000">
+              <a:srgbClr val="0C2B33">
+                <a:alpha val="10000"/>
+              </a:srgbClr>
+            </a:outerShdw>
+          </a:effectLst>
+        </p:spPr>
+      </p:sp>
+      <p:sp>
+        <p:nvSpPr>
+          <p:cNvPr id="29" name="Text 27"/>
+          <p:cNvSpPr/>
+          <p:nvPr/>
+        </p:nvSpPr>
+        <p:spPr>
+          <a:xfrm>
+            <a:off x="914400" y="4983480"/>
+            <a:ext cx="10332720" cy="868680"/>
+          </a:xfrm>
+          <a:prstGeom prst="rect">
+            <a:avLst/>
+          </a:prstGeom>
+          <a:noFill/>
+          <a:ln/>
+        </p:spPr>
+        <p:txBody>
+          <a:bodyPr wrap="square" lIns="0" tIns="0" rIns="0" bIns="0" rtlCol="0" anchor="ctr"/>
+          <a:lstStyle/>
+          <a:p>
+            <a:pPr indent="0" marL="0">
+              <a:buNone/>
+            </a:pPr>
+            <a:r>
+              <a:rPr lang="en-US" sz="1300" dirty="0">
+                <a:solidFill>
+                  <a:srgbClr val="A9C9CE"/>
+                </a:solidFill>
+                <a:latin typeface="Calibri" pitchFamily="34" charset="0"/>
+                <a:ea typeface="Calibri" pitchFamily="34" charset="-122"/>
+                <a:cs typeface="Calibri" pitchFamily="34" charset="-120"/>
+              </a:rPr>
+              <a:t>Banner only:  </a:t>
+            </a:r>
+            <a:pPr indent="0" marL="0">
+              <a:buNone/>
+            </a:pPr>
+            <a:r>
+              <a:rPr lang="en-US" sz="1300" b="1" dirty="0">
+                <a:solidFill>
+                  <a:srgbClr val="FFFFFF"/>
+                </a:solidFill>
+                <a:latin typeface="Calibri" pitchFamily="34" charset="0"/>
+                <a:ea typeface="Calibri" pitchFamily="34" charset="-122"/>
+                <a:cs typeface="Calibri" pitchFamily="34" charset="-120"/>
+              </a:rPr>
+              <a:t>40.3% clicked</a:t>
+            </a:r>
+            <a:pPr indent="0" marL="0">
+              <a:buNone/>
+            </a:pPr>
+            <a:r>
+              <a:rPr lang="en-US" sz="1200" dirty="0">
+                <a:solidFill>
+                  <a:srgbClr val="8FB4BA"/>
+                </a:solidFill>
+                <a:latin typeface="Calibri" pitchFamily="34" charset="0"/>
+                <a:ea typeface="Calibri" pitchFamily="34" charset="-122"/>
+                <a:cs typeface="Calibri" pitchFamily="34" charset="-120"/>
+              </a:rPr>
+              <a:t>  (11,106 viewers)          </a:t>
+            </a:r>
+            <a:pPr indent="0" marL="0">
+              <a:buNone/>
+            </a:pPr>
+            <a:r>
+              <a:rPr lang="en-US" sz="1300" dirty="0">
+                <a:solidFill>
+                  <a:srgbClr val="A9C9CE"/>
+                </a:solidFill>
+                <a:latin typeface="Calibri" pitchFamily="34" charset="0"/>
+                <a:ea typeface="Calibri" pitchFamily="34" charset="-122"/>
+                <a:cs typeface="Calibri" pitchFamily="34" charset="-120"/>
+              </a:rPr>
+              <a:t>Saw both channels:  </a:t>
+            </a:r>
+            <a:pPr indent="0" marL="0">
+              <a:buNone/>
+            </a:pPr>
+            <a:r>
+              <a:rPr lang="en-US" sz="1300" b="1" dirty="0">
+                <a:solidFill>
+                  <a:srgbClr val="02C39A"/>
+                </a:solidFill>
+                <a:latin typeface="Calibri" pitchFamily="34" charset="0"/>
+                <a:ea typeface="Calibri" pitchFamily="34" charset="-122"/>
+                <a:cs typeface="Calibri" pitchFamily="34" charset="-120"/>
+              </a:rPr>
+              <a:t>90.9% clicked</a:t>
+            </a:r>
+            <a:pPr indent="0" marL="0">
+              <a:buNone/>
+            </a:pPr>
+            <a:r>
+              <a:rPr lang="en-US" sz="1200" dirty="0">
+                <a:solidFill>
+                  <a:srgbClr val="8FB4BA"/>
+                </a:solidFill>
+                <a:latin typeface="Calibri" pitchFamily="34" charset="0"/>
+                <a:ea typeface="Calibri" pitchFamily="34" charset="-122"/>
+                <a:cs typeface="Calibri" pitchFamily="34" charset="-120"/>
+              </a:rPr>
+              <a:t>  (77 viewers)</a:t>
+            </a:r>
+            <a:endParaRPr lang="en-US" sz="1300" dirty="0"/>
+          </a:p>
+        </p:txBody>
+      </p:sp>
+      <p:sp>
+        <p:nvSpPr>
+          <p:cNvPr id="30" name="Text 28"/>
+          <p:cNvSpPr/>
+          <p:nvPr/>
+        </p:nvSpPr>
+        <p:spPr>
+          <a:xfrm>
+            <a:off x="548640" y="6035040"/>
+            <a:ext cx="11064240" cy="365760"/>
+          </a:xfrm>
+          <a:prstGeom prst="rect">
+            <a:avLst/>
+          </a:prstGeom>
+          <a:noFill/>
+          <a:ln/>
+        </p:spPr>
+        <p:txBody>
+          <a:bodyPr wrap="square" lIns="0" tIns="0" rIns="0" bIns="0" rtlCol="0" anchor="ctr"/>
+          <a:lstStyle/>
+          <a:p>
+            <a:pPr indent="0" marL="0">
+              <a:buNone/>
+            </a:pPr>
+            <a:r>
+              <a:rPr lang="en-US" sz="1050" i="1" dirty="0">
+                <a:solidFill>
+                  <a:srgbClr val="6E878E"/>
+                </a:solidFill>
+                <a:latin typeface="Calibri" pitchFamily="34" charset="0"/>
+                <a:ea typeface="Calibri" pitchFamily="34" charset="-122"/>
+                <a:cs typeface="Calibri" pitchFamily="34" charset="-120"/>
+              </a:rPr>
+              <a:t>Directional only: push reached 78 people, recipients were not randomly selected and there was no holdout, so part of the gap may be targeting rather than channel.</a:t>
+            </a:r>
+            <a:endParaRPr lang="en-US" sz="1050" dirty="0"/>
+          </a:p>
+        </p:txBody>
+      </p:sp>
+    </p:spTree>
+  </p:cSld>
+  <p:clrMapOvr>
+    <a:masterClrMapping/>
+  </p:clrMapOvr>
+</p:sld>
+</file>
+
+<file path=ppt/slides/slide8.xml><?xml version="1.0" encoding="utf-8"?>
+<p:sld xmlns:a="http://schemas.openxmlformats.org/drawingml/2006/main" xmlns:r="http://schemas.openxmlformats.org/officeDocument/2006/relationships" xmlns:p="http://schemas.openxmlformats.org/presentationml/2006/main">
+  <p:cSld name="Slide 8">
+    <p:bg>
+      <p:bgPr>
+        <a:solidFill>
           <a:srgbClr val="0C2B33"/>
         </a:solidFill>
       </p:bgPr>
@@ -6212,7 +8976,7 @@
                 <a:ea typeface="Calibri" pitchFamily="34" charset="-122"/>
                 <a:cs typeface="Calibri" pitchFamily="34" charset="-120"/>
               </a:rPr>
-              <a:t>1,159 of 1,440 new customers never saw the campaign. They click at 45.6% when they do — this is the cheapest incremental volume available.</a:t>
+              <a:t>1,159 of 1,440 never saw the campaign, and none received a push. They click at 45.6% when reached — the cheapest incremental volume available.</a:t>
             </a:r>
             <a:endParaRPr lang="en-US" sz="1150" dirty="0"/>
           </a:p>
@@ -6345,7 +9109,7 @@
                 <a:ea typeface="Cambria" pitchFamily="34" charset="-122"/>
                 <a:cs typeface="Cambria" pitchFamily="34" charset="-120"/>
               </a:rPr>
-              <a:t>Fix the creative for Save Max holders</a:t>
+              <a:t>Scale the push test on Save Max</a:t>
             </a:r>
             <a:endParaRPr lang="en-US" sz="1700" dirty="0"/>
           </a:p>
@@ -6387,7 +9151,7 @@
                 <a:ea typeface="Calibri" pitchFamily="34" charset="-122"/>
                 <a:cs typeface="Calibri" pitchFamily="34" charset="-120"/>
               </a:rPr>
-              <a:t>4,040 saw it and did nothing. A 10pt lift in their 31.8% click rate is roughly 590 extra clicks — more than New can deliver in total.</a:t>
+              <a:t>4,040 saw the banner and did nothing. Push already converts this exact segment at 87.2% versus 30.9% — but only 78 have ever received one.</a:t>
             </a:r>
             <a:endParaRPr lang="en-US" sz="1150" dirty="0"/>
           </a:p>
@@ -6562,7 +9326,7 @@
                 <a:ea typeface="Calibri" pitchFamily="34" charset="-122"/>
                 <a:cs typeface="Calibri" pitchFamily="34" charset="-120"/>
               </a:rPr>
-              <a:t>97.1% reach and a 50.9% click rate already. Treat this segment as the benchmark and the control, not a target for further push.</a:t>
+              <a:t>97.1% reach and a 50.9% click rate on banner alone, with no push at all. Treat it as the benchmark and the holdout, not a target for more spend.</a:t>
             </a:r>
             <a:endParaRPr lang="en-US" sz="1150" dirty="0"/>
           </a:p>
@@ -6628,7 +9392,7 @@
                 <a:ea typeface="Calibri" pitchFamily="34" charset="-122"/>
                 <a:cs typeface="Calibri" pitchFamily="34" charset="-120"/>
               </a:rPr>
-              <a:t>The binding constraint is conversion, not coverage: 6,637 reached non-clickers versus 2,148 never reached.</a:t>
+              <a:t>Conversion is the constraint, not coverage — and the best channel has reached only 78 people.</a:t>
             </a:r>
             <a:endParaRPr lang="en-US" sz="1300" dirty="0"/>
           </a:p>

</xml_diff>

<commit_message>
Base banner figures on the SaveMore Home placement only
Banner metrics previously summed all three placements. They now use Home
alone: 127,981 views (6.8% of leads), 10,766 clicks (8.4% CTR), 11,183
conversions (103.9% of clicks).

Living Room and Pocket Landing stay in the campaign table for completeness,
marked and italicised as excluded, and the all-banner subtotal row is gone.
In-scope KPI totals are recalculated on Home plus the five push sends:
128,085 views, 10,848 clicks, 11,262 conversions across 6 of 8 campaigns.

Co-Authored-By: Claude Opus 5 <noreply@anthropic.com>
Claude-Session: https://claude.ai/code/session_01J32T3RCFTYXbmvp9iW7MJu
</commit_message>
<xml_diff>
--- a/decks/campaign_funnel_summary.pptx
+++ b/decks/campaign_funnel_summary.pptx
@@ -2513,7 +2513,7 @@
           <a:p>
             <a:r>
               <a:rPr lang="en-US" dirty="0"/>
-              <a:t>Banner Home is carrying the campaign: 127,981 of 138,637 views and 10,766 of 11,278 clicks. Living Room is a distant second and Pocket Landing has delivered nothing. The five push sends are near-identical cells of ~11.4k leads each but have produced only 104 views between them.</a:t>
+              <a:t>Banner = SaveMore Home only. Home delivers 127,981 views and 10,766 clicks. Living Room and Pocket Landing are shown but excluded: Living Room is a distant second and Pocket Landing has delivered nothing. The five push sends are near-identical cells of ~11.4k leads each but have produced only 104 views between them.</a:t>
             </a:r>
             <a:endParaRPr lang="en-US" dirty="0"/>
           </a:p>
@@ -2601,7 +2601,7 @@
           <a:p>
             <a:r>
               <a:rPr lang="en-US" dirty="0"/>
-              <a:t>Banner loses people at the click (8.1% of views) but reaches 7.3% of its pool. Push is the mirror image: 78.8% click rate but only 0.2% of assigned leads ever saw it. Two flags: the deep funnel is instrumented on push only, and the conversion metric is inconsistent across placements.</a:t>
+              <a:t>Banner (Home only) loses people at the click (8.4% of views) but reaches 6.8% of its pool. Push is the mirror image: 78.8% click rate but only 0.2% of assigned leads ever saw it. Two flags: the deep funnel is instrumented on push only, and the conversion metric is inconsistent across placements.</a:t>
             </a:r>
             <a:endParaRPr lang="en-US" dirty="0"/>
           </a:p>
@@ -9719,7 +9719,7 @@
                 <a:ea typeface="Calibri" pitchFamily="34" charset="-122"/>
                 <a:cs typeface="Calibri" pitchFamily="34" charset="-120"/>
               </a:rPr>
-              <a:t>CLICX SaveMore, live 17 Aug 2026 — banner placements run to 30 Sep, push sends to 31 Aug.</a:t>
+              <a:t>CLICX SaveMore, live 17 Aug 2026. Banner figures use the SaveMore Home placement only.</a:t>
             </a:r>
             <a:endParaRPr lang="en-US" sz="1400" dirty="0"/>
           </a:p>
@@ -9792,7 +9792,7 @@
                 <a:ea typeface="Cambria" pitchFamily="34" charset="-122"/>
                 <a:cs typeface="Cambria" pitchFamily="34" charset="-120"/>
               </a:rPr>
-              <a:t>8</a:t>
+              <a:t>6</a:t>
             </a:r>
             <a:endParaRPr lang="en-US" sz="2400" dirty="0"/>
           </a:p>
@@ -9831,7 +9831,7 @@
                 <a:ea typeface="Calibri" pitchFamily="34" charset="-122"/>
                 <a:cs typeface="Calibri" pitchFamily="34" charset="-120"/>
               </a:rPr>
-              <a:t>campaigns live</a:t>
+              <a:t>campaigns in scope</a:t>
             </a:r>
             <a:pPr indent="0" marL="0">
               <a:buNone/>
@@ -9845,7 +9845,7 @@
                 <a:ea typeface="Calibri" pitchFamily="34" charset="-122"/>
                 <a:cs typeface="Calibri" pitchFamily="34" charset="-120"/>
               </a:rPr>
-              <a:t>   7 delivering</a:t>
+              <a:t>   of 8</a:t>
             </a:r>
             <a:endParaRPr lang="en-US" sz="1150" dirty="0"/>
           </a:p>
@@ -9918,7 +9918,7 @@
                 <a:ea typeface="Cambria" pitchFamily="34" charset="-122"/>
                 <a:cs typeface="Cambria" pitchFamily="34" charset="-120"/>
               </a:rPr>
-              <a:t>138,637</a:t>
+              <a:t>128,085</a:t>
             </a:r>
             <a:endParaRPr lang="en-US" sz="2400" dirty="0"/>
           </a:p>
@@ -10044,7 +10044,7 @@
                 <a:ea typeface="Cambria" pitchFamily="34" charset="-122"/>
                 <a:cs typeface="Cambria" pitchFamily="34" charset="-120"/>
               </a:rPr>
-              <a:t>11,278</a:t>
+              <a:t>10,848</a:t>
             </a:r>
             <a:endParaRPr lang="en-US" sz="2400" dirty="0"/>
           </a:p>
@@ -10097,7 +10097,7 @@
                 <a:ea typeface="Calibri" pitchFamily="34" charset="-122"/>
                 <a:cs typeface="Calibri" pitchFamily="34" charset="-120"/>
               </a:rPr>
-              <a:t>   99.3% from banner</a:t>
+              <a:t>   99.2% from banner</a:t>
             </a:r>
             <a:endParaRPr lang="en-US" sz="1150" dirty="0"/>
           </a:p>
@@ -10170,7 +10170,7 @@
                 <a:ea typeface="Cambria" pitchFamily="34" charset="-122"/>
                 <a:cs typeface="Cambria" pitchFamily="34" charset="-120"/>
               </a:rPr>
-              <a:t>11,485</a:t>
+              <a:t>11,262</a:t>
             </a:r>
             <a:endParaRPr lang="en-US" sz="2400" dirty="0"/>
           </a:p>
@@ -10259,7 +10259,7 @@
                 <a:gridCol w="1097280"/>
                 <a:gridCol w="2011680"/>
               </a:tblGrid>
-              <a:tr h="260604">
+              <a:tr h="274320">
                 <a:tc>
                   <a:txBody>
                     <a:bodyPr/>
@@ -10669,7 +10669,7 @@
                   </a:tcPr>
                 </a:tc>
               </a:tr>
-              <a:tr h="260604">
+              <a:tr h="274320">
                 <a:tc>
                   <a:txBody>
                     <a:bodyPr/>
@@ -11079,7 +11079,7 @@
                   </a:tcPr>
                 </a:tc>
               </a:tr>
-              <a:tr h="260604">
+              <a:tr h="274320">
                 <a:tc>
                   <a:txBody>
                     <a:bodyPr/>
@@ -11089,15 +11089,15 @@
                         <a:buNone/>
                       </a:pPr>
                       <a:r>
-                        <a:rPr lang="en-US" sz="1050" b="1" dirty="0">
+                        <a:rPr lang="en-US" sz="1050" i="1" dirty="0">
                           <a:solidFill>
-                            <a:srgbClr val="33484F"/>
+                            <a:srgbClr val="6E878E"/>
                           </a:solidFill>
                           <a:latin typeface="Calibri" pitchFamily="34" charset="0"/>
                           <a:ea typeface="Calibri" pitchFamily="34" charset="-122"/>
                           <a:cs typeface="Calibri" pitchFamily="34" charset="-120"/>
                         </a:rPr>
-                        <a:t>Banner — Living Room</a:t>
+                        <a:t>Banner — Living Room †</a:t>
                       </a:r>
                       <a:endParaRPr lang="en-US" sz="1050" dirty="0">
                         <a:latin typeface="Calibri" charset="0"/>
@@ -11157,9 +11157,9 @@
                         <a:buNone/>
                       </a:pPr>
                       <a:r>
-                        <a:rPr lang="en-US" sz="1050" dirty="0">
+                        <a:rPr lang="en-US" sz="1050" i="1" dirty="0">
                           <a:solidFill>
-                            <a:srgbClr val="33484F"/>
+                            <a:srgbClr val="6E878E"/>
                           </a:solidFill>
                           <a:latin typeface="Calibri" pitchFamily="34" charset="0"/>
                           <a:ea typeface="Calibri" pitchFamily="34" charset="-122"/>
@@ -11225,9 +11225,9 @@
                         <a:buNone/>
                       </a:pPr>
                       <a:r>
-                        <a:rPr lang="en-US" sz="1050" dirty="0">
+                        <a:rPr lang="en-US" sz="1050" i="1" dirty="0">
                           <a:solidFill>
-                            <a:srgbClr val="33484F"/>
+                            <a:srgbClr val="6E878E"/>
                           </a:solidFill>
                           <a:latin typeface="Calibri" pitchFamily="34" charset="0"/>
                           <a:ea typeface="Calibri" pitchFamily="34" charset="-122"/>
@@ -11293,9 +11293,9 @@
                         <a:buNone/>
                       </a:pPr>
                       <a:r>
-                        <a:rPr lang="en-US" sz="1050" dirty="0">
+                        <a:rPr lang="en-US" sz="1050" i="1" dirty="0">
                           <a:solidFill>
-                            <a:srgbClr val="33484F"/>
+                            <a:srgbClr val="6E878E"/>
                           </a:solidFill>
                           <a:latin typeface="Calibri" pitchFamily="34" charset="0"/>
                           <a:ea typeface="Calibri" pitchFamily="34" charset="-122"/>
@@ -11361,9 +11361,9 @@
                         <a:buNone/>
                       </a:pPr>
                       <a:r>
-                        <a:rPr lang="en-US" sz="1050" dirty="0">
+                        <a:rPr lang="en-US" sz="1050" i="1" dirty="0">
                           <a:solidFill>
-                            <a:srgbClr val="33484F"/>
+                            <a:srgbClr val="6E878E"/>
                           </a:solidFill>
                           <a:latin typeface="Calibri" pitchFamily="34" charset="0"/>
                           <a:ea typeface="Calibri" pitchFamily="34" charset="-122"/>
@@ -11429,9 +11429,9 @@
                         <a:buNone/>
                       </a:pPr>
                       <a:r>
-                        <a:rPr lang="en-US" sz="1050" dirty="0">
+                        <a:rPr lang="en-US" sz="1050" i="1" dirty="0">
                           <a:solidFill>
-                            <a:srgbClr val="33484F"/>
+                            <a:srgbClr val="6E878E"/>
                           </a:solidFill>
                           <a:latin typeface="Calibri" pitchFamily="34" charset="0"/>
                           <a:ea typeface="Calibri" pitchFamily="34" charset="-122"/>
@@ -11489,7 +11489,7 @@
                   </a:tcPr>
                 </a:tc>
               </a:tr>
-              <a:tr h="260604">
+              <a:tr h="274320">
                 <a:tc>
                   <a:txBody>
                     <a:bodyPr/>
@@ -11499,15 +11499,15 @@
                         <a:buNone/>
                       </a:pPr>
                       <a:r>
-                        <a:rPr lang="en-US" sz="1050" b="1" dirty="0">
+                        <a:rPr lang="en-US" sz="1050" i="1" dirty="0">
                           <a:solidFill>
-                            <a:srgbClr val="33484F"/>
+                            <a:srgbClr val="6E878E"/>
                           </a:solidFill>
                           <a:latin typeface="Calibri" pitchFamily="34" charset="0"/>
                           <a:ea typeface="Calibri" pitchFamily="34" charset="-122"/>
                           <a:cs typeface="Calibri" pitchFamily="34" charset="-120"/>
                         </a:rPr>
-                        <a:t>Banner — Pocket Landing</a:t>
+                        <a:t>Banner — Pocket Landing †</a:t>
                       </a:r>
                       <a:endParaRPr lang="en-US" sz="1050" dirty="0">
                         <a:latin typeface="Calibri" charset="0"/>
@@ -11567,9 +11567,9 @@
                         <a:buNone/>
                       </a:pPr>
                       <a:r>
-                        <a:rPr lang="en-US" sz="1050" dirty="0">
+                        <a:rPr lang="en-US" sz="1050" i="1" dirty="0">
                           <a:solidFill>
-                            <a:srgbClr val="33484F"/>
+                            <a:srgbClr val="6E878E"/>
                           </a:solidFill>
                           <a:latin typeface="Calibri" pitchFamily="34" charset="0"/>
                           <a:ea typeface="Calibri" pitchFamily="34" charset="-122"/>
@@ -11635,7 +11635,7 @@
                         <a:buNone/>
                       </a:pPr>
                       <a:r>
-                        <a:rPr lang="en-US" sz="1050" dirty="0">
+                        <a:rPr lang="en-US" sz="1050" i="1" dirty="0">
                           <a:solidFill>
                             <a:srgbClr val="6E878E"/>
                           </a:solidFill>
@@ -11703,7 +11703,7 @@
                         <a:buNone/>
                       </a:pPr>
                       <a:r>
-                        <a:rPr lang="en-US" sz="1050" dirty="0">
+                        <a:rPr lang="en-US" sz="1050" i="1" dirty="0">
                           <a:solidFill>
                             <a:srgbClr val="6E878E"/>
                           </a:solidFill>
@@ -11771,7 +11771,7 @@
                         <a:buNone/>
                       </a:pPr>
                       <a:r>
-                        <a:rPr lang="en-US" sz="1050" dirty="0">
+                        <a:rPr lang="en-US" sz="1050" i="1" dirty="0">
                           <a:solidFill>
                             <a:srgbClr val="6E878E"/>
                           </a:solidFill>
@@ -11839,7 +11839,7 @@
                         <a:buNone/>
                       </a:pPr>
                       <a:r>
-                        <a:rPr lang="en-US" sz="1050" dirty="0">
+                        <a:rPr lang="en-US" sz="1050" i="1" dirty="0">
                           <a:solidFill>
                             <a:srgbClr val="6E878E"/>
                           </a:solidFill>
@@ -11899,7 +11899,7 @@
                   </a:tcPr>
                 </a:tc>
               </a:tr>
-              <a:tr h="260604">
+              <a:tr h="274320">
                 <a:tc>
                   <a:txBody>
                     <a:bodyPr/>
@@ -12309,7 +12309,7 @@
                   </a:tcPr>
                 </a:tc>
               </a:tr>
-              <a:tr h="260604">
+              <a:tr h="274320">
                 <a:tc>
                   <a:txBody>
                     <a:bodyPr/>
@@ -12719,7 +12719,7 @@
                   </a:tcPr>
                 </a:tc>
               </a:tr>
-              <a:tr h="260604">
+              <a:tr h="274320">
                 <a:tc>
                   <a:txBody>
                     <a:bodyPr/>
@@ -13129,7 +13129,7 @@
                   </a:tcPr>
                 </a:tc>
               </a:tr>
-              <a:tr h="260604">
+              <a:tr h="274320">
                 <a:tc>
                   <a:txBody>
                     <a:bodyPr/>
@@ -13539,7 +13539,7 @@
                   </a:tcPr>
                 </a:tc>
               </a:tr>
-              <a:tr h="260604">
+              <a:tr h="274320">
                 <a:tc>
                   <a:txBody>
                     <a:bodyPr/>
@@ -13949,417 +13949,7 @@
                   </a:tcPr>
                 </a:tc>
               </a:tr>
-              <a:tr h="260604">
-                <a:tc>
-                  <a:txBody>
-                    <a:bodyPr/>
-                    <a:lstStyle/>
-                    <a:p>
-                      <a:pPr algn="l" indent="0" marL="0">
-                        <a:buNone/>
-                      </a:pPr>
-                      <a:r>
-                        <a:rPr lang="en-US" sz="1050" b="1" dirty="0">
-                          <a:solidFill>
-                            <a:srgbClr val="0C2B33"/>
-                          </a:solidFill>
-                          <a:latin typeface="Calibri" pitchFamily="34" charset="0"/>
-                          <a:ea typeface="Calibri" pitchFamily="34" charset="-122"/>
-                          <a:cs typeface="Calibri" pitchFamily="34" charset="-120"/>
-                        </a:rPr>
-                        <a:t>All banner (3 placements)</a:t>
-                      </a:r>
-                      <a:endParaRPr lang="en-US" sz="1050" dirty="0">
-                        <a:latin typeface="Calibri" charset="0"/>
-                        <a:ea typeface="Calibri" charset="0"/>
-                        <a:cs typeface="Calibri" charset="0"/>
-                      </a:endParaRPr>
-                    </a:p>
-                  </a:txBody>
-                  <a:tcPr marL="82296" marR="82296" marT="36576" marB="36576" anchor="ctr">
-                    <a:lnL w="12700" cap="flat" cmpd="sng" algn="ctr">
-                      <a:solidFill>
-                        <a:srgbClr val="DDE9E9"/>
-                      </a:solidFill>
-                      <a:prstDash val="solid"/>
-                      <a:round/>
-                      <a:headEnd type="none" w="med" len="med"/>
-                      <a:tailEnd type="none" w="med" len="med"/>
-                    </a:lnL>
-                    <a:lnR w="12700" cap="flat" cmpd="sng" algn="ctr">
-                      <a:solidFill>
-                        <a:srgbClr val="DDE9E9"/>
-                      </a:solidFill>
-                      <a:prstDash val="solid"/>
-                      <a:round/>
-                      <a:headEnd type="none" w="med" len="med"/>
-                      <a:tailEnd type="none" w="med" len="med"/>
-                    </a:lnR>
-                    <a:lnT w="12700" cap="flat" cmpd="sng" algn="ctr">
-                      <a:solidFill>
-                        <a:srgbClr val="DDE9E9"/>
-                      </a:solidFill>
-                      <a:prstDash val="solid"/>
-                      <a:round/>
-                      <a:headEnd type="none" w="med" len="med"/>
-                      <a:tailEnd type="none" w="med" len="med"/>
-                    </a:lnT>
-                    <a:lnB w="12700" cap="flat" cmpd="sng" algn="ctr">
-                      <a:solidFill>
-                        <a:srgbClr val="DDE9E9"/>
-                      </a:solidFill>
-                      <a:prstDash val="solid"/>
-                      <a:round/>
-                      <a:headEnd type="none" w="med" len="med"/>
-                      <a:tailEnd type="none" w="med" len="med"/>
-                    </a:lnB>
-                    <a:solidFill>
-                      <a:srgbClr val="E3EEEE"/>
-                    </a:solidFill>
-                  </a:tcPr>
-                </a:tc>
-                <a:tc>
-                  <a:txBody>
-                    <a:bodyPr/>
-                    <a:lstStyle/>
-                    <a:p>
-                      <a:pPr algn="r" indent="0" marL="0">
-                        <a:buNone/>
-                      </a:pPr>
-                      <a:r>
-                        <a:rPr lang="en-US" sz="1050" b="1" dirty="0">
-                          <a:solidFill>
-                            <a:srgbClr val="0C2B33"/>
-                          </a:solidFill>
-                          <a:latin typeface="Calibri" pitchFamily="34" charset="0"/>
-                          <a:ea typeface="Calibri" pitchFamily="34" charset="-122"/>
-                          <a:cs typeface="Calibri" pitchFamily="34" charset="-120"/>
-                        </a:rPr>
-                        <a:t>1,891,142*</a:t>
-                      </a:r>
-                      <a:endParaRPr lang="en-US" sz="1050" dirty="0">
-                        <a:latin typeface="Calibri" charset="0"/>
-                        <a:ea typeface="Calibri" charset="0"/>
-                        <a:cs typeface="Calibri" charset="0"/>
-                      </a:endParaRPr>
-                    </a:p>
-                  </a:txBody>
-                  <a:tcPr marL="82296" marR="82296" marT="36576" marB="36576" anchor="ctr">
-                    <a:lnL w="12700" cap="flat" cmpd="sng" algn="ctr">
-                      <a:solidFill>
-                        <a:srgbClr val="DDE9E9"/>
-                      </a:solidFill>
-                      <a:prstDash val="solid"/>
-                      <a:round/>
-                      <a:headEnd type="none" w="med" len="med"/>
-                      <a:tailEnd type="none" w="med" len="med"/>
-                    </a:lnL>
-                    <a:lnR w="12700" cap="flat" cmpd="sng" algn="ctr">
-                      <a:solidFill>
-                        <a:srgbClr val="DDE9E9"/>
-                      </a:solidFill>
-                      <a:prstDash val="solid"/>
-                      <a:round/>
-                      <a:headEnd type="none" w="med" len="med"/>
-                      <a:tailEnd type="none" w="med" len="med"/>
-                    </a:lnR>
-                    <a:lnT w="12700" cap="flat" cmpd="sng" algn="ctr">
-                      <a:solidFill>
-                        <a:srgbClr val="DDE9E9"/>
-                      </a:solidFill>
-                      <a:prstDash val="solid"/>
-                      <a:round/>
-                      <a:headEnd type="none" w="med" len="med"/>
-                      <a:tailEnd type="none" w="med" len="med"/>
-                    </a:lnT>
-                    <a:lnB w="12700" cap="flat" cmpd="sng" algn="ctr">
-                      <a:solidFill>
-                        <a:srgbClr val="DDE9E9"/>
-                      </a:solidFill>
-                      <a:prstDash val="solid"/>
-                      <a:round/>
-                      <a:headEnd type="none" w="med" len="med"/>
-                      <a:tailEnd type="none" w="med" len="med"/>
-                    </a:lnB>
-                    <a:solidFill>
-                      <a:srgbClr val="E3EEEE"/>
-                    </a:solidFill>
-                  </a:tcPr>
-                </a:tc>
-                <a:tc>
-                  <a:txBody>
-                    <a:bodyPr/>
-                    <a:lstStyle/>
-                    <a:p>
-                      <a:pPr algn="r" indent="0" marL="0">
-                        <a:buNone/>
-                      </a:pPr>
-                      <a:r>
-                        <a:rPr lang="en-US" sz="1050" b="1" dirty="0">
-                          <a:solidFill>
-                            <a:srgbClr val="0C2B33"/>
-                          </a:solidFill>
-                          <a:latin typeface="Calibri" pitchFamily="34" charset="0"/>
-                          <a:ea typeface="Calibri" pitchFamily="34" charset="-122"/>
-                          <a:cs typeface="Calibri" pitchFamily="34" charset="-120"/>
-                        </a:rPr>
-                        <a:t>138,533</a:t>
-                      </a:r>
-                      <a:endParaRPr lang="en-US" sz="1050" dirty="0">
-                        <a:latin typeface="Calibri" charset="0"/>
-                        <a:ea typeface="Calibri" charset="0"/>
-                        <a:cs typeface="Calibri" charset="0"/>
-                      </a:endParaRPr>
-                    </a:p>
-                  </a:txBody>
-                  <a:tcPr marL="82296" marR="82296" marT="36576" marB="36576" anchor="ctr">
-                    <a:lnL w="12700" cap="flat" cmpd="sng" algn="ctr">
-                      <a:solidFill>
-                        <a:srgbClr val="DDE9E9"/>
-                      </a:solidFill>
-                      <a:prstDash val="solid"/>
-                      <a:round/>
-                      <a:headEnd type="none" w="med" len="med"/>
-                      <a:tailEnd type="none" w="med" len="med"/>
-                    </a:lnL>
-                    <a:lnR w="12700" cap="flat" cmpd="sng" algn="ctr">
-                      <a:solidFill>
-                        <a:srgbClr val="DDE9E9"/>
-                      </a:solidFill>
-                      <a:prstDash val="solid"/>
-                      <a:round/>
-                      <a:headEnd type="none" w="med" len="med"/>
-                      <a:tailEnd type="none" w="med" len="med"/>
-                    </a:lnR>
-                    <a:lnT w="12700" cap="flat" cmpd="sng" algn="ctr">
-                      <a:solidFill>
-                        <a:srgbClr val="DDE9E9"/>
-                      </a:solidFill>
-                      <a:prstDash val="solid"/>
-                      <a:round/>
-                      <a:headEnd type="none" w="med" len="med"/>
-                      <a:tailEnd type="none" w="med" len="med"/>
-                    </a:lnT>
-                    <a:lnB w="12700" cap="flat" cmpd="sng" algn="ctr">
-                      <a:solidFill>
-                        <a:srgbClr val="DDE9E9"/>
-                      </a:solidFill>
-                      <a:prstDash val="solid"/>
-                      <a:round/>
-                      <a:headEnd type="none" w="med" len="med"/>
-                      <a:tailEnd type="none" w="med" len="med"/>
-                    </a:lnB>
-                    <a:solidFill>
-                      <a:srgbClr val="E3EEEE"/>
-                    </a:solidFill>
-                  </a:tcPr>
-                </a:tc>
-                <a:tc>
-                  <a:txBody>
-                    <a:bodyPr/>
-                    <a:lstStyle/>
-                    <a:p>
-                      <a:pPr algn="r" indent="0" marL="0">
-                        <a:buNone/>
-                      </a:pPr>
-                      <a:r>
-                        <a:rPr lang="en-US" sz="1050" b="1" dirty="0">
-                          <a:solidFill>
-                            <a:srgbClr val="0C2B33"/>
-                          </a:solidFill>
-                          <a:latin typeface="Calibri" pitchFamily="34" charset="0"/>
-                          <a:ea typeface="Calibri" pitchFamily="34" charset="-122"/>
-                          <a:cs typeface="Calibri" pitchFamily="34" charset="-120"/>
-                        </a:rPr>
-                        <a:t>11,196</a:t>
-                      </a:r>
-                      <a:endParaRPr lang="en-US" sz="1050" dirty="0">
-                        <a:latin typeface="Calibri" charset="0"/>
-                        <a:ea typeface="Calibri" charset="0"/>
-                        <a:cs typeface="Calibri" charset="0"/>
-                      </a:endParaRPr>
-                    </a:p>
-                  </a:txBody>
-                  <a:tcPr marL="82296" marR="82296" marT="36576" marB="36576" anchor="ctr">
-                    <a:lnL w="12700" cap="flat" cmpd="sng" algn="ctr">
-                      <a:solidFill>
-                        <a:srgbClr val="DDE9E9"/>
-                      </a:solidFill>
-                      <a:prstDash val="solid"/>
-                      <a:round/>
-                      <a:headEnd type="none" w="med" len="med"/>
-                      <a:tailEnd type="none" w="med" len="med"/>
-                    </a:lnL>
-                    <a:lnR w="12700" cap="flat" cmpd="sng" algn="ctr">
-                      <a:solidFill>
-                        <a:srgbClr val="DDE9E9"/>
-                      </a:solidFill>
-                      <a:prstDash val="solid"/>
-                      <a:round/>
-                      <a:headEnd type="none" w="med" len="med"/>
-                      <a:tailEnd type="none" w="med" len="med"/>
-                    </a:lnR>
-                    <a:lnT w="12700" cap="flat" cmpd="sng" algn="ctr">
-                      <a:solidFill>
-                        <a:srgbClr val="DDE9E9"/>
-                      </a:solidFill>
-                      <a:prstDash val="solid"/>
-                      <a:round/>
-                      <a:headEnd type="none" w="med" len="med"/>
-                      <a:tailEnd type="none" w="med" len="med"/>
-                    </a:lnT>
-                    <a:lnB w="12700" cap="flat" cmpd="sng" algn="ctr">
-                      <a:solidFill>
-                        <a:srgbClr val="DDE9E9"/>
-                      </a:solidFill>
-                      <a:prstDash val="solid"/>
-                      <a:round/>
-                      <a:headEnd type="none" w="med" len="med"/>
-                      <a:tailEnd type="none" w="med" len="med"/>
-                    </a:lnB>
-                    <a:solidFill>
-                      <a:srgbClr val="E3EEEE"/>
-                    </a:solidFill>
-                  </a:tcPr>
-                </a:tc>
-                <a:tc>
-                  <a:txBody>
-                    <a:bodyPr/>
-                    <a:lstStyle/>
-                    <a:p>
-                      <a:pPr algn="r" indent="0" marL="0">
-                        <a:buNone/>
-                      </a:pPr>
-                      <a:r>
-                        <a:rPr lang="en-US" sz="1050" b="1" dirty="0">
-                          <a:solidFill>
-                            <a:srgbClr val="0C2B33"/>
-                          </a:solidFill>
-                          <a:latin typeface="Calibri" pitchFamily="34" charset="0"/>
-                          <a:ea typeface="Calibri" pitchFamily="34" charset="-122"/>
-                          <a:cs typeface="Calibri" pitchFamily="34" charset="-120"/>
-                        </a:rPr>
-                        <a:t>8.1%</a:t>
-                      </a:r>
-                      <a:endParaRPr lang="en-US" sz="1050" dirty="0">
-                        <a:latin typeface="Calibri" charset="0"/>
-                        <a:ea typeface="Calibri" charset="0"/>
-                        <a:cs typeface="Calibri" charset="0"/>
-                      </a:endParaRPr>
-                    </a:p>
-                  </a:txBody>
-                  <a:tcPr marL="82296" marR="82296" marT="36576" marB="36576" anchor="ctr">
-                    <a:lnL w="12700" cap="flat" cmpd="sng" algn="ctr">
-                      <a:solidFill>
-                        <a:srgbClr val="DDE9E9"/>
-                      </a:solidFill>
-                      <a:prstDash val="solid"/>
-                      <a:round/>
-                      <a:headEnd type="none" w="med" len="med"/>
-                      <a:tailEnd type="none" w="med" len="med"/>
-                    </a:lnL>
-                    <a:lnR w="12700" cap="flat" cmpd="sng" algn="ctr">
-                      <a:solidFill>
-                        <a:srgbClr val="DDE9E9"/>
-                      </a:solidFill>
-                      <a:prstDash val="solid"/>
-                      <a:round/>
-                      <a:headEnd type="none" w="med" len="med"/>
-                      <a:tailEnd type="none" w="med" len="med"/>
-                    </a:lnR>
-                    <a:lnT w="12700" cap="flat" cmpd="sng" algn="ctr">
-                      <a:solidFill>
-                        <a:srgbClr val="DDE9E9"/>
-                      </a:solidFill>
-                      <a:prstDash val="solid"/>
-                      <a:round/>
-                      <a:headEnd type="none" w="med" len="med"/>
-                      <a:tailEnd type="none" w="med" len="med"/>
-                    </a:lnT>
-                    <a:lnB w="12700" cap="flat" cmpd="sng" algn="ctr">
-                      <a:solidFill>
-                        <a:srgbClr val="DDE9E9"/>
-                      </a:solidFill>
-                      <a:prstDash val="solid"/>
-                      <a:round/>
-                      <a:headEnd type="none" w="med" len="med"/>
-                      <a:tailEnd type="none" w="med" len="med"/>
-                    </a:lnB>
-                    <a:solidFill>
-                      <a:srgbClr val="E3EEEE"/>
-                    </a:solidFill>
-                  </a:tcPr>
-                </a:tc>
-                <a:tc>
-                  <a:txBody>
-                    <a:bodyPr/>
-                    <a:lstStyle/>
-                    <a:p>
-                      <a:pPr algn="r" indent="0" marL="0">
-                        <a:buNone/>
-                      </a:pPr>
-                      <a:r>
-                        <a:rPr lang="en-US" sz="1050" b="1" dirty="0">
-                          <a:solidFill>
-                            <a:srgbClr val="0C2B33"/>
-                          </a:solidFill>
-                          <a:latin typeface="Calibri" pitchFamily="34" charset="0"/>
-                          <a:ea typeface="Calibri" pitchFamily="34" charset="-122"/>
-                          <a:cs typeface="Calibri" pitchFamily="34" charset="-120"/>
-                        </a:rPr>
-                        <a:t>11,406</a:t>
-                      </a:r>
-                      <a:endParaRPr lang="en-US" sz="1050" dirty="0">
-                        <a:latin typeface="Calibri" charset="0"/>
-                        <a:ea typeface="Calibri" charset="0"/>
-                        <a:cs typeface="Calibri" charset="0"/>
-                      </a:endParaRPr>
-                    </a:p>
-                  </a:txBody>
-                  <a:tcPr marL="82296" marR="82296" marT="36576" marB="36576" anchor="ctr">
-                    <a:lnL w="12700" cap="flat" cmpd="sng" algn="ctr">
-                      <a:solidFill>
-                        <a:srgbClr val="DDE9E9"/>
-                      </a:solidFill>
-                      <a:prstDash val="solid"/>
-                      <a:round/>
-                      <a:headEnd type="none" w="med" len="med"/>
-                      <a:tailEnd type="none" w="med" len="med"/>
-                    </a:lnL>
-                    <a:lnR w="12700" cap="flat" cmpd="sng" algn="ctr">
-                      <a:solidFill>
-                        <a:srgbClr val="DDE9E9"/>
-                      </a:solidFill>
-                      <a:prstDash val="solid"/>
-                      <a:round/>
-                      <a:headEnd type="none" w="med" len="med"/>
-                      <a:tailEnd type="none" w="med" len="med"/>
-                    </a:lnR>
-                    <a:lnT w="12700" cap="flat" cmpd="sng" algn="ctr">
-                      <a:solidFill>
-                        <a:srgbClr val="DDE9E9"/>
-                      </a:solidFill>
-                      <a:prstDash val="solid"/>
-                      <a:round/>
-                      <a:headEnd type="none" w="med" len="med"/>
-                      <a:tailEnd type="none" w="med" len="med"/>
-                    </a:lnT>
-                    <a:lnB w="12700" cap="flat" cmpd="sng" algn="ctr">
-                      <a:solidFill>
-                        <a:srgbClr val="DDE9E9"/>
-                      </a:solidFill>
-                      <a:prstDash val="solid"/>
-                      <a:round/>
-                      <a:headEnd type="none" w="med" len="med"/>
-                      <a:tailEnd type="none" w="med" len="med"/>
-                    </a:lnB>
-                    <a:solidFill>
-                      <a:srgbClr val="E3EEEE"/>
-                    </a:solidFill>
-                  </a:tcPr>
-                </a:tc>
-              </a:tr>
-              <a:tr h="260604">
+              <a:tr h="274320">
                 <a:tc>
                   <a:txBody>
                     <a:bodyPr/>
@@ -14781,8 +14371,8 @@
         </p:nvSpPr>
         <p:spPr>
           <a:xfrm>
-            <a:off x="548640" y="6016752"/>
-            <a:ext cx="11064240" cy="457200"/>
+            <a:off x="548640" y="5852160"/>
+            <a:ext cx="11064240" cy="502920"/>
           </a:xfrm>
           <a:prstGeom prst="rect">
             <a:avLst/>
@@ -14809,7 +14399,7 @@
                 <a:ea typeface="Calibri" pitchFamily="34" charset="-122"/>
                 <a:cs typeface="Calibri" pitchFamily="34" charset="-120"/>
               </a:rPr>
-              <a:t>*The three banner placements share one audience pool of 1,891,142, so their leads are not additive. Pocket Landing has recorded no delivery at all. No applications, approvals or bookings have been recorded on any campaign yet.</a:t>
+              <a:t>† Living Room and Pocket Landing are listed for completeness but excluded from the analysis; Pocket Landing has recorded no delivery at all. All three banner placements draw on the same 1,891,142 audience pool, so their leads are not additive. No applications, approvals or bookings have been recorded on any campaign yet.</a:t>
             </a:r>
             <a:endParaRPr lang="en-US" sz="1050" dirty="0"/>
           </a:p>
@@ -14958,7 +14548,7 @@
                 <a:ea typeface="Calibri" pitchFamily="34" charset="-122"/>
                 <a:cs typeface="Calibri" pitchFamily="34" charset="-120"/>
               </a:rPr>
-              <a:t>Same four stages, two channels that fail and succeed at opposite ends of the funnel.</a:t>
+              <a:t>Banner is the SaveMore Home placement. The two channels fail and succeed at opposite ends of the funnel.</a:t>
             </a:r>
             <a:endParaRPr lang="en-US" sz="1400" dirty="0"/>
           </a:p>
@@ -15022,7 +14612,7 @@
                 <a:ea typeface="Calibri" pitchFamily="34" charset="-122"/>
                 <a:cs typeface="Calibri" pitchFamily="34" charset="-120"/>
               </a:rPr>
-              <a:t>Banner</a:t>
+              <a:t>Banner — Home</a:t>
             </a:r>
             <a:endParaRPr lang="en-US" sz="1500" dirty="0"/>
           </a:p>
@@ -15061,7 +14651,7 @@
                 <a:ea typeface="Calibri" pitchFamily="34" charset="-122"/>
                 <a:cs typeface="Calibri" pitchFamily="34" charset="-120"/>
               </a:rPr>
-              <a:t>3 placements, one shared pool</a:t>
+              <a:t>SaveMore Home placement only</a:t>
             </a:r>
             <a:endParaRPr lang="en-US" sz="1100" dirty="0"/>
           </a:p>
@@ -15310,7 +14900,7 @@
                 <a:ea typeface="Cambria" pitchFamily="34" charset="-122"/>
                 <a:cs typeface="Cambria" pitchFamily="34" charset="-120"/>
               </a:rPr>
-              <a:t>138,533</a:t>
+              <a:t>127,981</a:t>
             </a:r>
             <a:endParaRPr lang="en-US" sz="1900" dirty="0"/>
           </a:p>
@@ -15349,7 +14939,7 @@
                 <a:ea typeface="Calibri" pitchFamily="34" charset="-122"/>
                 <a:cs typeface="Calibri" pitchFamily="34" charset="-120"/>
               </a:rPr>
-              <a:t>7.3% of leads</a:t>
+              <a:t>6.8% of leads</a:t>
             </a:r>
             <a:endParaRPr lang="en-US" sz="1100" dirty="0"/>
           </a:p>
@@ -15454,7 +15044,7 @@
                 <a:ea typeface="Cambria" pitchFamily="34" charset="-122"/>
                 <a:cs typeface="Cambria" pitchFamily="34" charset="-120"/>
               </a:rPr>
-              <a:t>11,196</a:t>
+              <a:t>10,766</a:t>
             </a:r>
             <a:endParaRPr lang="en-US" sz="1900" dirty="0"/>
           </a:p>
@@ -15493,7 +15083,7 @@
                 <a:ea typeface="Calibri" pitchFamily="34" charset="-122"/>
                 <a:cs typeface="Calibri" pitchFamily="34" charset="-120"/>
               </a:rPr>
-              <a:t>8.1% of views</a:t>
+              <a:t>8.4% of views</a:t>
             </a:r>
             <a:endParaRPr lang="en-US" sz="1100" dirty="0"/>
           </a:p>
@@ -15598,7 +15188,7 @@
                 <a:ea typeface="Cambria" pitchFamily="34" charset="-122"/>
                 <a:cs typeface="Cambria" pitchFamily="34" charset="-120"/>
               </a:rPr>
-              <a:t>11,406</a:t>
+              <a:t>11,183</a:t>
             </a:r>
             <a:endParaRPr lang="en-US" sz="1900" dirty="0"/>
           </a:p>
@@ -15637,7 +15227,7 @@
                 <a:ea typeface="Calibri" pitchFamily="34" charset="-122"/>
                 <a:cs typeface="Calibri" pitchFamily="34" charset="-120"/>
               </a:rPr>
-              <a:t>101.9% of clicks</a:t>
+              <a:t>103.9% of clicks</a:t>
             </a:r>
             <a:endParaRPr lang="en-US" sz="1100" dirty="0"/>
           </a:p>
@@ -16431,7 +16021,7 @@
                 <a:ea typeface="Calibri" pitchFamily="34" charset="-122"/>
                 <a:cs typeface="Calibri" pitchFamily="34" charset="-120"/>
               </a:rPr>
-              <a:t>82 clicks → 51 detail-page views (62.2%) → 29 through the door (56.9%). The banner placements record none of these events, so nothing below the click can be compared.</a:t>
+              <a:t>82 clicks → 51 detail-page views (62.2%) → 29 through the door (56.9%). Banner records none of these events, so nothing below the click can be compared.</a:t>
             </a:r>
             <a:endParaRPr lang="en-US" sz="1100" dirty="0"/>
           </a:p>

</xml_diff>